<commit_message>
For Bug 36035 70425 Update translations of layouts and templates of Slide masters for zh-CN template. Change default margins of Document amd Form template according to regional settings
</commit_message>
<xml_diff>
--- a/new/zh-CN/new.pptx
+++ b/new/zh-CN/new.pptx
@@ -2,7 +2,7 @@
 <file path=ppt/presentation.xml><?xml version="1.0" encoding="utf-8"?>
 <p:presentation xmlns:a="http://schemas.openxmlformats.org/drawingml/2006/main" xmlns:r="http://schemas.openxmlformats.org/officeDocument/2006/relationships" xmlns:p="http://schemas.openxmlformats.org/presentationml/2006/main" saveSubsetFonts="1">
   <p:sldMasterIdLst>
-    <p:sldMasterId id="2147483672" r:id="rId1"/>
+    <p:sldMasterId id="2147483648" r:id="rId1"/>
   </p:sldMasterIdLst>
   <p:notesMasterIdLst>
     <p:notesMasterId r:id="rId3"/>
@@ -16,8 +16,8 @@
     <a:defPPr>
       <a:defRPr lang="zh-CN"/>
     </a:defPPr>
-    <a:lvl1pPr marL="0" algn="l" defTabSz="914400" rtl="0" eaLnBrk="1" latinLnBrk="0" hangingPunct="1">
-      <a:defRPr sz="1800" kern="1200">
+    <a:lvl1pPr marL="0" algn="l" defTabSz="914400" rtl="0">
+      <a:defRPr sz="1800">
         <a:solidFill>
           <a:schemeClr val="tx1"/>
         </a:solidFill>
@@ -26,8 +26,8 @@
         <a:cs typeface="+mn-cs"/>
       </a:defRPr>
     </a:lvl1pPr>
-    <a:lvl2pPr marL="457200" algn="l" defTabSz="914400" rtl="0" eaLnBrk="1" latinLnBrk="0" hangingPunct="1">
-      <a:defRPr sz="1800" kern="1200">
+    <a:lvl2pPr marL="457200" algn="l" defTabSz="914400" rtl="0">
+      <a:defRPr sz="1800">
         <a:solidFill>
           <a:schemeClr val="tx1"/>
         </a:solidFill>
@@ -36,8 +36,8 @@
         <a:cs typeface="+mn-cs"/>
       </a:defRPr>
     </a:lvl2pPr>
-    <a:lvl3pPr marL="914400" algn="l" defTabSz="914400" rtl="0" eaLnBrk="1" latinLnBrk="0" hangingPunct="1">
-      <a:defRPr sz="1800" kern="1200">
+    <a:lvl3pPr marL="914400" algn="l" defTabSz="914400" rtl="0">
+      <a:defRPr sz="1800">
         <a:solidFill>
           <a:schemeClr val="tx1"/>
         </a:solidFill>
@@ -46,8 +46,8 @@
         <a:cs typeface="+mn-cs"/>
       </a:defRPr>
     </a:lvl3pPr>
-    <a:lvl4pPr marL="1371600" algn="l" defTabSz="914400" rtl="0" eaLnBrk="1" latinLnBrk="0" hangingPunct="1">
-      <a:defRPr sz="1800" kern="1200">
+    <a:lvl4pPr marL="1371600" algn="l" defTabSz="914400" rtl="0">
+      <a:defRPr sz="1800">
         <a:solidFill>
           <a:schemeClr val="tx1"/>
         </a:solidFill>
@@ -56,8 +56,8 @@
         <a:cs typeface="+mn-cs"/>
       </a:defRPr>
     </a:lvl4pPr>
-    <a:lvl5pPr marL="1828800" algn="l" defTabSz="914400" rtl="0" eaLnBrk="1" latinLnBrk="0" hangingPunct="1">
-      <a:defRPr sz="1800" kern="1200">
+    <a:lvl5pPr marL="1828800" algn="l" defTabSz="914400" rtl="0">
+      <a:defRPr sz="1800">
         <a:solidFill>
           <a:schemeClr val="tx1"/>
         </a:solidFill>
@@ -66,8 +66,8 @@
         <a:cs typeface="+mn-cs"/>
       </a:defRPr>
     </a:lvl5pPr>
-    <a:lvl6pPr marL="2286000" algn="l" defTabSz="914400" rtl="0" eaLnBrk="1" latinLnBrk="0" hangingPunct="1">
-      <a:defRPr sz="1800" kern="1200">
+    <a:lvl6pPr marL="2286000" algn="l" defTabSz="914400" rtl="0">
+      <a:defRPr sz="1800">
         <a:solidFill>
           <a:schemeClr val="tx1"/>
         </a:solidFill>
@@ -76,8 +76,8 @@
         <a:cs typeface="+mn-cs"/>
       </a:defRPr>
     </a:lvl6pPr>
-    <a:lvl7pPr marL="2743200" algn="l" defTabSz="914400" rtl="0" eaLnBrk="1" latinLnBrk="0" hangingPunct="1">
-      <a:defRPr sz="1800" kern="1200">
+    <a:lvl7pPr marL="2743200" algn="l" defTabSz="914400" rtl="0">
+      <a:defRPr sz="1800">
         <a:solidFill>
           <a:schemeClr val="tx1"/>
         </a:solidFill>
@@ -86,8 +86,8 @@
         <a:cs typeface="+mn-cs"/>
       </a:defRPr>
     </a:lvl7pPr>
-    <a:lvl8pPr marL="3200400" algn="l" defTabSz="914400" rtl="0" eaLnBrk="1" latinLnBrk="0" hangingPunct="1">
-      <a:defRPr sz="1800" kern="1200">
+    <a:lvl8pPr marL="3200400" algn="l" defTabSz="914400" rtl="0">
+      <a:defRPr sz="1800">
         <a:solidFill>
           <a:schemeClr val="tx1"/>
         </a:solidFill>
@@ -96,8 +96,8 @@
         <a:cs typeface="+mn-cs"/>
       </a:defRPr>
     </a:lvl8pPr>
-    <a:lvl9pPr marL="3657600" algn="l" defTabSz="914400" rtl="0" eaLnBrk="1" latinLnBrk="0" hangingPunct="1">
-      <a:defRPr sz="1800" kern="1200">
+    <a:lvl9pPr marL="3657600" algn="l" defTabSz="914400" rtl="0">
+      <a:defRPr sz="1800">
         <a:solidFill>
           <a:schemeClr val="tx1"/>
         </a:solidFill>
@@ -109,10 +109,18 @@
   </p:defaultTextStyle>
   <p:extLst>
     <p:ext uri="{EFAFB233-063F-42B5-8137-9DF3F51BA10A}">
-      <p15:sldGuideLst xmlns:p15="http://schemas.microsoft.com/office/powerpoint/2012/main"/>
-    </p:ext>
-    <p:ext uri="{2D200454-40CA-4A62-9FC3-DE9A4176ACB9}">
-      <p15:notesGuideLst xmlns:p15="http://schemas.microsoft.com/office/powerpoint/2012/main"/>
+      <p15:sldGuideLst xmlns:p15="http://schemas.microsoft.com/office/powerpoint/2012/main">
+        <p15:guide id="1" pos="3840">
+          <p15:clr>
+            <a:srgbClr val="A4A3A4"/>
+          </p15:clr>
+        </p15:guide>
+        <p15:guide id="2" orient="horz" pos="2160">
+          <p15:clr>
+            <a:srgbClr val="A4A3A4"/>
+          </p15:clr>
+        </p15:guide>
+      </p15:sldGuideLst>
     </p:ext>
   </p:extLst>
 </p:presentation>
@@ -132,7 +140,7 @@
         <p:cNvGrpSpPr/>
         <p:nvPr/>
       </p:nvGrpSpPr>
-      <p:grpSpPr>
+      <p:grpSpPr bwMode="auto">
         <a:xfrm>
           <a:off x="0" y="0"/>
           <a:ext cx="0" cy="0"/>
@@ -142,7 +150,7 @@
       </p:grpSpPr>
       <p:sp>
         <p:nvSpPr>
-          <p:cNvPr id="2" name="Header Placeholder 1"/>
+          <p:cNvPr id="926586711" name="頁首預留位置 1"/>
           <p:cNvSpPr>
             <a:spLocks noGrp="1"/>
           </p:cNvSpPr>
@@ -150,7 +158,7 @@
             <p:ph type="hdr" sz="quarter"/>
           </p:nvPr>
         </p:nvSpPr>
-        <p:spPr>
+        <p:spPr bwMode="auto">
           <a:xfrm>
             <a:off x="0" y="0"/>
             <a:ext cx="2971800" cy="458788"/>
@@ -167,13 +175,16 @@
             </a:lvl1pPr>
           </a:lstStyle>
           <a:p>
+            <a:pPr>
+              <a:defRPr/>
+            </a:pPr>
             <a:endParaRPr lang="zh-CN"/>
           </a:p>
         </p:txBody>
       </p:sp>
       <p:sp>
         <p:nvSpPr>
-          <p:cNvPr id="3" name="Date Placeholder 2"/>
+          <p:cNvPr id="1990681168" name="日期預留位置 2"/>
           <p:cNvSpPr>
             <a:spLocks noGrp="1"/>
           </p:cNvSpPr>
@@ -181,7 +192,7 @@
             <p:ph type="dt" idx="1"/>
           </p:nvPr>
         </p:nvSpPr>
-        <p:spPr>
+        <p:spPr bwMode="auto">
           <a:xfrm>
             <a:off x="3884613" y="0"/>
             <a:ext cx="2971800" cy="458788"/>
@@ -198,9 +209,12 @@
             </a:lvl1pPr>
           </a:lstStyle>
           <a:p>
+            <a:pPr>
+              <a:defRPr/>
+            </a:pPr>
             <a:fld id="{3632E96E-41F7-40C5-8419-297958CC00FA}" type="datetimeFigureOut">
-              <a:rPr lang="zh-CN" smtClean="0"/>
-              <a:t>10/30/2013</a:t>
+              <a:rPr lang="en-US" altLang="zh-CN"/>
+              <a:t>2026/4/10</a:t>
             </a:fld>
             <a:endParaRPr lang="zh-CN"/>
           </a:p>
@@ -208,7 +222,7 @@
       </p:sp>
       <p:sp>
         <p:nvSpPr>
-          <p:cNvPr id="4" name="Slide Image Placeholder 3"/>
+          <p:cNvPr id="2066252378" name="投影片影像預留位置 3"/>
           <p:cNvSpPr>
             <a:spLocks noGrp="1" noRot="1" noChangeAspect="1"/>
           </p:cNvSpPr>
@@ -216,7 +230,7 @@
             <p:ph type="sldImg" idx="2"/>
           </p:nvPr>
         </p:nvSpPr>
-        <p:spPr>
+        <p:spPr bwMode="auto">
           <a:xfrm>
             <a:off x="685800" y="1143000"/>
             <a:ext cx="5486400" cy="3086100"/>
@@ -235,13 +249,16 @@
           <a:bodyPr vert="horz" lIns="91440" tIns="45720" rIns="91440" bIns="45720" rtlCol="0" anchor="ctr"/>
           <a:lstStyle/>
           <a:p>
+            <a:pPr>
+              <a:defRPr/>
+            </a:pPr>
             <a:endParaRPr lang="zh-CN"/>
           </a:p>
         </p:txBody>
       </p:sp>
       <p:sp>
         <p:nvSpPr>
-          <p:cNvPr id="5" name="Notes Placeholder 4"/>
+          <p:cNvPr id="798861881" name="備忘稿預留位置 4"/>
           <p:cNvSpPr>
             <a:spLocks noGrp="1"/>
           </p:cNvSpPr>
@@ -249,7 +266,7 @@
             <p:ph type="body" sz="quarter" idx="3"/>
           </p:nvPr>
         </p:nvSpPr>
-        <p:spPr>
+        <p:spPr bwMode="auto">
           <a:xfrm>
             <a:off x="685800" y="4400550"/>
             <a:ext cx="5486400" cy="3600450"/>
@@ -262,46 +279,59 @@
           <a:bodyPr vert="horz" lIns="91440" tIns="45720" rIns="91440" bIns="45720" rtlCol="0"/>
           <a:lstStyle/>
           <a:p>
-            <a:pPr lvl="0"/>
-            <a:r>
-              <a:rPr lang="zh-CN" smtClean="0"/>
-              <a:t>Click to edit Master text styles</a:t>
-            </a:r>
-          </a:p>
-          <a:p>
-            <a:pPr lvl="1"/>
-            <a:r>
-              <a:rPr lang="zh-CN" smtClean="0"/>
-              <a:t>Second level</a:t>
-            </a:r>
-          </a:p>
-          <a:p>
-            <a:pPr lvl="2"/>
-            <a:r>
-              <a:rPr lang="zh-CN" smtClean="0"/>
-              <a:t>Third level</a:t>
-            </a:r>
-          </a:p>
-          <a:p>
-            <a:pPr lvl="3"/>
-            <a:r>
-              <a:rPr lang="zh-CN" smtClean="0"/>
-              <a:t>Fourth level</a:t>
-            </a:r>
-          </a:p>
-          <a:p>
-            <a:pPr lvl="4"/>
-            <a:r>
-              <a:rPr lang="zh-CN" smtClean="0"/>
-              <a:t>Fifth level</a:t>
-            </a:r>
-            <a:endParaRPr lang="zh-CN"/>
-          </a:p>
-        </p:txBody>
-      </p:sp>
-      <p:sp>
-        <p:nvSpPr>
-          <p:cNvPr id="6" name="Footer Placeholder 5"/>
+            <a:pPr lvl="0">
+              <a:defRPr/>
+            </a:pPr>
+            <a:r>
+              <a:rPr lang="zh-CN"/>
+              <a:t>单击此处编辑母版文本样式</a:t>
+            </a:r>
+            <a:endParaRPr/>
+          </a:p>
+          <a:p>
+            <a:pPr lvl="1">
+              <a:defRPr/>
+            </a:pPr>
+            <a:r>
+              <a:rPr lang="zh-CN"/>
+              <a:t>二级</a:t>
+            </a:r>
+            <a:endParaRPr/>
+          </a:p>
+          <a:p>
+            <a:pPr lvl="2">
+              <a:defRPr/>
+            </a:pPr>
+            <a:r>
+              <a:rPr lang="zh-CN"/>
+              <a:t>三级</a:t>
+            </a:r>
+            <a:endParaRPr/>
+          </a:p>
+          <a:p>
+            <a:pPr lvl="3">
+              <a:defRPr/>
+            </a:pPr>
+            <a:r>
+              <a:rPr lang="zh-CN"/>
+              <a:t>四级</a:t>
+            </a:r>
+            <a:endParaRPr/>
+          </a:p>
+          <a:p>
+            <a:pPr lvl="4">
+              <a:defRPr/>
+            </a:pPr>
+            <a:r>
+              <a:rPr lang="zh-CN"/>
+              <a:t>五级</a:t>
+            </a:r>
+          </a:p>
+        </p:txBody>
+      </p:sp>
+      <p:sp>
+        <p:nvSpPr>
+          <p:cNvPr id="1854493174" name="頁尾預留位置 5"/>
           <p:cNvSpPr>
             <a:spLocks noGrp="1"/>
           </p:cNvSpPr>
@@ -309,7 +339,7 @@
             <p:ph type="ftr" sz="quarter" idx="4"/>
           </p:nvPr>
         </p:nvSpPr>
-        <p:spPr>
+        <p:spPr bwMode="auto">
           <a:xfrm>
             <a:off x="0" y="8685213"/>
             <a:ext cx="2971800" cy="458787"/>
@@ -326,13 +356,16 @@
             </a:lvl1pPr>
           </a:lstStyle>
           <a:p>
+            <a:pPr>
+              <a:defRPr/>
+            </a:pPr>
             <a:endParaRPr lang="zh-CN"/>
           </a:p>
         </p:txBody>
       </p:sp>
       <p:sp>
         <p:nvSpPr>
-          <p:cNvPr id="7" name="Slide Number Placeholder 6"/>
+          <p:cNvPr id="125502887" name="投影片編號預留位置 6"/>
           <p:cNvSpPr>
             <a:spLocks noGrp="1"/>
           </p:cNvSpPr>
@@ -340,7 +373,7 @@
             <p:ph type="sldNum" sz="quarter" idx="5"/>
           </p:nvPr>
         </p:nvSpPr>
-        <p:spPr>
+        <p:spPr bwMode="auto">
           <a:xfrm>
             <a:off x="3884613" y="8685213"/>
             <a:ext cx="2971800" cy="458787"/>
@@ -357,8 +390,11 @@
             </a:lvl1pPr>
           </a:lstStyle>
           <a:p>
+            <a:pPr>
+              <a:defRPr/>
+            </a:pPr>
             <a:fld id="{2E6999B8-B6B4-4561-A3CD-BBCDAB9FC9D9}" type="slidenum">
-              <a:rPr lang="zh-CN" smtClean="0"/>
+              <a:rPr lang="zh-CN"/>
               <a:t>‹#›</a:t>
             </a:fld>
             <a:endParaRPr lang="zh-CN"/>
@@ -366,16 +402,11 @@
         </p:txBody>
       </p:sp>
     </p:spTree>
-    <p:extLst>
-      <p:ext uri="{BB962C8B-B14F-4D97-AF65-F5344CB8AC3E}">
-        <p14:creationId xmlns:p14="http://schemas.microsoft.com/office/powerpoint/2010/main" val="2743286597"/>
-      </p:ext>
-    </p:extLst>
   </p:cSld>
   <p:clrMap bg1="lt1" tx1="dk1" bg2="lt2" tx2="dk2" accent1="accent1" accent2="accent2" accent3="accent3" accent4="accent4" accent5="accent5" accent6="accent6" hlink="hlink" folHlink="folHlink"/>
   <p:notesStyle>
-    <a:lvl1pPr marL="0" algn="l" defTabSz="914400" rtl="0" eaLnBrk="1" latinLnBrk="0" hangingPunct="1">
-      <a:defRPr sz="1200" kern="1200">
+    <a:lvl1pPr marL="0" algn="l" defTabSz="914400" rtl="0">
+      <a:defRPr sz="1200">
         <a:solidFill>
           <a:schemeClr val="tx1"/>
         </a:solidFill>
@@ -384,8 +415,8 @@
         <a:cs typeface="+mn-cs"/>
       </a:defRPr>
     </a:lvl1pPr>
-    <a:lvl2pPr marL="457200" algn="l" defTabSz="914400" rtl="0" eaLnBrk="1" latinLnBrk="0" hangingPunct="1">
-      <a:defRPr sz="1200" kern="1200">
+    <a:lvl2pPr marL="457200" algn="l" defTabSz="914400" rtl="0">
+      <a:defRPr sz="1200">
         <a:solidFill>
           <a:schemeClr val="tx1"/>
         </a:solidFill>
@@ -394,8 +425,8 @@
         <a:cs typeface="+mn-cs"/>
       </a:defRPr>
     </a:lvl2pPr>
-    <a:lvl3pPr marL="914400" algn="l" defTabSz="914400" rtl="0" eaLnBrk="1" latinLnBrk="0" hangingPunct="1">
-      <a:defRPr sz="1200" kern="1200">
+    <a:lvl3pPr marL="914400" algn="l" defTabSz="914400" rtl="0">
+      <a:defRPr sz="1200">
         <a:solidFill>
           <a:schemeClr val="tx1"/>
         </a:solidFill>
@@ -404,8 +435,8 @@
         <a:cs typeface="+mn-cs"/>
       </a:defRPr>
     </a:lvl3pPr>
-    <a:lvl4pPr marL="1371600" algn="l" defTabSz="914400" rtl="0" eaLnBrk="1" latinLnBrk="0" hangingPunct="1">
-      <a:defRPr sz="1200" kern="1200">
+    <a:lvl4pPr marL="1371600" algn="l" defTabSz="914400" rtl="0">
+      <a:defRPr sz="1200">
         <a:solidFill>
           <a:schemeClr val="tx1"/>
         </a:solidFill>
@@ -414,8 +445,8 @@
         <a:cs typeface="+mn-cs"/>
       </a:defRPr>
     </a:lvl4pPr>
-    <a:lvl5pPr marL="1828800" algn="l" defTabSz="914400" rtl="0" eaLnBrk="1" latinLnBrk="0" hangingPunct="1">
-      <a:defRPr sz="1200" kern="1200">
+    <a:lvl5pPr marL="1828800" algn="l" defTabSz="914400" rtl="0">
+      <a:defRPr sz="1200">
         <a:solidFill>
           <a:schemeClr val="tx1"/>
         </a:solidFill>
@@ -424,8 +455,8 @@
         <a:cs typeface="+mn-cs"/>
       </a:defRPr>
     </a:lvl5pPr>
-    <a:lvl6pPr marL="2286000" algn="l" defTabSz="914400" rtl="0" eaLnBrk="1" latinLnBrk="0" hangingPunct="1">
-      <a:defRPr sz="1200" kern="1200">
+    <a:lvl6pPr marL="2286000" algn="l" defTabSz="914400" rtl="0">
+      <a:defRPr sz="1200">
         <a:solidFill>
           <a:schemeClr val="tx1"/>
         </a:solidFill>
@@ -434,8 +465,8 @@
         <a:cs typeface="+mn-cs"/>
       </a:defRPr>
     </a:lvl6pPr>
-    <a:lvl7pPr marL="2743200" algn="l" defTabSz="914400" rtl="0" eaLnBrk="1" latinLnBrk="0" hangingPunct="1">
-      <a:defRPr sz="1200" kern="1200">
+    <a:lvl7pPr marL="2743200" algn="l" defTabSz="914400" rtl="0">
+      <a:defRPr sz="1200">
         <a:solidFill>
           <a:schemeClr val="tx1"/>
         </a:solidFill>
@@ -444,8 +475,8 @@
         <a:cs typeface="+mn-cs"/>
       </a:defRPr>
     </a:lvl7pPr>
-    <a:lvl8pPr marL="3200400" algn="l" defTabSz="914400" rtl="0" eaLnBrk="1" latinLnBrk="0" hangingPunct="1">
-      <a:defRPr sz="1200" kern="1200">
+    <a:lvl8pPr marL="3200400" algn="l" defTabSz="914400" rtl="0">
+      <a:defRPr sz="1200">
         <a:solidFill>
           <a:schemeClr val="tx1"/>
         </a:solidFill>
@@ -454,8 +485,8 @@
         <a:cs typeface="+mn-cs"/>
       </a:defRPr>
     </a:lvl8pPr>
-    <a:lvl9pPr marL="3657600" algn="l" defTabSz="914400" rtl="0" eaLnBrk="1" latinLnBrk="0" hangingPunct="1">
-      <a:defRPr sz="1200" kern="1200">
+    <a:lvl9pPr marL="3657600" algn="l" defTabSz="914400" rtl="0">
+      <a:defRPr sz="1200">
         <a:solidFill>
           <a:schemeClr val="tx1"/>
         </a:solidFill>
@@ -477,7 +508,7 @@
         <p:cNvGrpSpPr/>
         <p:nvPr/>
       </p:nvGrpSpPr>
-      <p:grpSpPr>
+      <p:grpSpPr bwMode="auto">
         <a:xfrm>
           <a:off x="0" y="0"/>
           <a:ext cx="0" cy="0"/>
@@ -487,7 +518,7 @@
       </p:grpSpPr>
       <p:sp>
         <p:nvSpPr>
-          <p:cNvPr id="2" name="Slide Image Placeholder 1"/>
+          <p:cNvPr id="691496501" name="投影片影像預留位置 1"/>
           <p:cNvSpPr>
             <a:spLocks noGrp="1" noRot="1" noChangeAspect="1"/>
           </p:cNvSpPr>
@@ -495,7 +526,7 @@
             <p:ph type="sldImg"/>
           </p:nvPr>
         </p:nvSpPr>
-        <p:spPr>
+        <p:spPr bwMode="auto">
           <a:xfrm>
             <a:off x="685800" y="1143000"/>
             <a:ext cx="5486400" cy="3086100"/>
@@ -504,7 +535,7 @@
       </p:sp>
       <p:sp>
         <p:nvSpPr>
-          <p:cNvPr id="3" name="Notes Placeholder 2"/>
+          <p:cNvPr id="1862948544" name="備忘稿預留位置 2"/>
           <p:cNvSpPr>
             <a:spLocks noGrp="1"/>
           </p:cNvSpPr>
@@ -512,21 +543,24 @@
             <p:ph type="body" idx="1"/>
           </p:nvPr>
         </p:nvSpPr>
-        <p:spPr/>
-        <p:txBody>
-          <a:bodyPr/>
-          <a:lstStyle/>
-          <a:p>
-            <a:endParaRPr lang="zh-CN" dirty="0">
-              <a:latin typeface="Arial" panose="020B0604020202020204" pitchFamily="34" charset="0"/>
-              <a:cs typeface="Arial" panose="020B0604020202020204" pitchFamily="34" charset="0"/>
+        <p:spPr bwMode="auto"/>
+        <p:txBody>
+          <a:bodyPr/>
+          <a:lstStyle/>
+          <a:p>
+            <a:pPr>
+              <a:defRPr/>
+            </a:pPr>
+            <a:endParaRPr lang="zh-CN">
+              <a:latin typeface="Arial"/>
+              <a:cs typeface="Arial"/>
             </a:endParaRPr>
           </a:p>
         </p:txBody>
       </p:sp>
       <p:sp>
         <p:nvSpPr>
-          <p:cNvPr id="4" name="Slide Number Placeholder 3"/>
+          <p:cNvPr id="1565800824" name="投影片編號預留位置 3"/>
           <p:cNvSpPr>
             <a:spLocks noGrp="1"/>
           </p:cNvSpPr>
@@ -534,13 +568,16 @@
             <p:ph type="sldNum" sz="quarter" idx="10"/>
           </p:nvPr>
         </p:nvSpPr>
-        <p:spPr/>
-        <p:txBody>
-          <a:bodyPr/>
-          <a:lstStyle/>
-          <a:p>
+        <p:spPr bwMode="auto"/>
+        <p:txBody>
+          <a:bodyPr/>
+          <a:lstStyle/>
+          <a:p>
+            <a:pPr>
+              <a:defRPr/>
+            </a:pPr>
             <a:fld id="{2E6999B8-B6B4-4561-A3CD-BBCDAB9FC9D9}" type="slidenum">
-              <a:rPr lang="zh-CN" smtClean="0"/>
+              <a:rPr lang="zh-CN"/>
               <a:t>1</a:t>
             </a:fld>
             <a:endParaRPr lang="zh-CN"/>
@@ -548,11 +585,6 @@
         </p:txBody>
       </p:sp>
     </p:spTree>
-    <p:extLst>
-      <p:ext uri="{BB962C8B-B14F-4D97-AF65-F5344CB8AC3E}">
-        <p14:creationId xmlns:p14="http://schemas.microsoft.com/office/powerpoint/2010/main" val="867644256"/>
-      </p:ext>
-    </p:extLst>
   </p:cSld>
   <p:clrMapOvr>
     <a:masterClrMapping/>
@@ -561,15 +593,15 @@
 </file>
 
 <file path=ppt/slideLayouts/slideLayout1.xml><?xml version="1.0" encoding="utf-8"?>
-<p:sldLayout xmlns:a="http://schemas.openxmlformats.org/drawingml/2006/main" xmlns:r="http://schemas.openxmlformats.org/officeDocument/2006/relationships" xmlns:p="http://schemas.openxmlformats.org/presentationml/2006/main" type="title" preserve="1">
-  <p:cSld name="Title Slide">
+<p:sldLayout xmlns:a="http://schemas.openxmlformats.org/drawingml/2006/main" xmlns:r="http://schemas.openxmlformats.org/officeDocument/2006/relationships" xmlns:p="http://schemas.openxmlformats.org/presentationml/2006/main" showMasterPhAnim="0" type="title" preserve="1" userDrawn="1">
+  <p:cSld name="标题幻灯片">
     <p:spTree>
       <p:nvGrpSpPr>
         <p:cNvPr id="1" name=""/>
         <p:cNvGrpSpPr/>
         <p:nvPr/>
       </p:nvGrpSpPr>
-      <p:grpSpPr>
+      <p:grpSpPr bwMode="auto">
         <a:xfrm>
           <a:off x="0" y="0"/>
           <a:ext cx="0" cy="0"/>
@@ -579,7 +611,7 @@
       </p:grpSpPr>
       <p:sp>
         <p:nvSpPr>
-          <p:cNvPr id="2" name="Title 1"/>
+          <p:cNvPr id="1401406964" name="标题 1"/>
           <p:cNvSpPr>
             <a:spLocks noGrp="1"/>
           </p:cNvSpPr>
@@ -587,7 +619,7 @@
             <p:ph type="ctrTitle"/>
           </p:nvPr>
         </p:nvSpPr>
-        <p:spPr>
+        <p:spPr bwMode="auto">
           <a:xfrm>
             <a:off x="1524000" y="1122363"/>
             <a:ext cx="9144000" cy="2387600"/>
@@ -601,17 +633,19 @@
             </a:lvl1pPr>
           </a:lstStyle>
           <a:p>
-            <a:r>
-              <a:rPr lang="zh-CN" smtClean="0"/>
-              <a:t>Click to edit Master title style</a:t>
-            </a:r>
-            <a:endParaRPr lang="zh-CN" dirty="0"/>
-          </a:p>
-        </p:txBody>
-      </p:sp>
-      <p:sp>
-        <p:nvSpPr>
-          <p:cNvPr id="3" name="Subtitle 2"/>
+            <a:pPr>
+              <a:defRPr/>
+            </a:pPr>
+            <a:r>
+              <a:rPr lang="zh-CN"/>
+              <a:t>单击此处编辑母版标题样式</a:t>
+            </a:r>
+          </a:p>
+        </p:txBody>
+      </p:sp>
+      <p:sp>
+        <p:nvSpPr>
+          <p:cNvPr id="463146695" name="副标题 2"/>
           <p:cNvSpPr>
             <a:spLocks noGrp="1"/>
           </p:cNvSpPr>
@@ -619,7 +653,7 @@
             <p:ph type="subTitle" idx="1"/>
           </p:nvPr>
         </p:nvSpPr>
-        <p:spPr>
+        <p:spPr bwMode="auto">
           <a:xfrm>
             <a:off x="1524000" y="3602038"/>
             <a:ext cx="9144000" cy="1655762"/>
@@ -666,17 +700,19 @@
             </a:lvl9pPr>
           </a:lstStyle>
           <a:p>
-            <a:r>
-              <a:rPr lang="zh-CN" smtClean="0"/>
-              <a:t>Click to edit Master subtitle style</a:t>
-            </a:r>
-            <a:endParaRPr lang="zh-CN" dirty="0"/>
-          </a:p>
-        </p:txBody>
-      </p:sp>
-      <p:sp>
-        <p:nvSpPr>
-          <p:cNvPr id="4" name="Date Placeholder 3"/>
+            <a:pPr>
+              <a:defRPr/>
+            </a:pPr>
+            <a:r>
+              <a:rPr lang="zh-CN"/>
+              <a:t>单击此处编辑母版副标题样式</a:t>
+            </a:r>
+          </a:p>
+        </p:txBody>
+      </p:sp>
+      <p:sp>
+        <p:nvSpPr>
+          <p:cNvPr id="254356156" name="日期占位符 3"/>
           <p:cNvSpPr>
             <a:spLocks noGrp="1"/>
           </p:cNvSpPr>
@@ -684,14 +720,17 @@
             <p:ph type="dt" sz="half" idx="10"/>
           </p:nvPr>
         </p:nvSpPr>
-        <p:spPr/>
-        <p:txBody>
-          <a:bodyPr/>
-          <a:lstStyle/>
-          <a:p>
+        <p:spPr bwMode="auto"/>
+        <p:txBody>
+          <a:bodyPr/>
+          <a:lstStyle/>
+          <a:p>
+            <a:pPr>
+              <a:defRPr/>
+            </a:pPr>
             <a:fld id="{BCC18F51-09EC-435C-A3BA-64A766E099C0}" type="datetimeFigureOut">
-              <a:rPr lang="zh-CN" smtClean="0"/>
-              <a:t>30.10.2013</a:t>
+              <a:rPr lang="en-US" altLang="zh-CN"/>
+              <a:t>2026/4/10</a:t>
             </a:fld>
             <a:endParaRPr lang="zh-CN"/>
           </a:p>
@@ -699,7 +738,7 @@
       </p:sp>
       <p:sp>
         <p:nvSpPr>
-          <p:cNvPr id="5" name="Footer Placeholder 4"/>
+          <p:cNvPr id="114962164" name="页脚占位符 4"/>
           <p:cNvSpPr>
             <a:spLocks noGrp="1"/>
           </p:cNvSpPr>
@@ -707,18 +746,21 @@
             <p:ph type="ftr" sz="quarter" idx="11"/>
           </p:nvPr>
         </p:nvSpPr>
-        <p:spPr/>
-        <p:txBody>
-          <a:bodyPr/>
-          <a:lstStyle/>
-          <a:p>
+        <p:spPr bwMode="auto"/>
+        <p:txBody>
+          <a:bodyPr/>
+          <a:lstStyle/>
+          <a:p>
+            <a:pPr>
+              <a:defRPr/>
+            </a:pPr>
             <a:endParaRPr lang="zh-CN"/>
           </a:p>
         </p:txBody>
       </p:sp>
       <p:sp>
         <p:nvSpPr>
-          <p:cNvPr id="6" name="Slide Number Placeholder 5"/>
+          <p:cNvPr id="713013020" name="灯片编号占位符 5"/>
           <p:cNvSpPr>
             <a:spLocks noGrp="1"/>
           </p:cNvSpPr>
@@ -726,13 +768,16 @@
             <p:ph type="sldNum" sz="quarter" idx="12"/>
           </p:nvPr>
         </p:nvSpPr>
-        <p:spPr/>
-        <p:txBody>
-          <a:bodyPr/>
-          <a:lstStyle/>
-          <a:p>
+        <p:spPr bwMode="auto"/>
+        <p:txBody>
+          <a:bodyPr/>
+          <a:lstStyle/>
+          <a:p>
+            <a:pPr>
+              <a:defRPr/>
+            </a:pPr>
             <a:fld id="{08395586-F03A-48D1-94DF-16B239DF4FB5}" type="slidenum">
-              <a:rPr lang="zh-CN" smtClean="0"/>
+              <a:rPr lang="zh-CN"/>
               <a:t>‹#›</a:t>
             </a:fld>
             <a:endParaRPr lang="zh-CN"/>
@@ -740,11 +785,6 @@
         </p:txBody>
       </p:sp>
     </p:spTree>
-    <p:extLst>
-      <p:ext uri="{BB962C8B-B14F-4D97-AF65-F5344CB8AC3E}">
-        <p14:creationId xmlns:p14="http://schemas.microsoft.com/office/powerpoint/2010/main" val="2520518546"/>
-      </p:ext>
-    </p:extLst>
   </p:cSld>
   <p:clrMapOvr>
     <a:masterClrMapping/>
@@ -753,15 +793,15 @@
 </file>
 
 <file path=ppt/slideLayouts/slideLayout10.xml><?xml version="1.0" encoding="utf-8"?>
-<p:sldLayout xmlns:a="http://schemas.openxmlformats.org/drawingml/2006/main" xmlns:r="http://schemas.openxmlformats.org/officeDocument/2006/relationships" xmlns:p="http://schemas.openxmlformats.org/presentationml/2006/main" type="vertTx" preserve="1">
-  <p:cSld name="Title and Vertical Text">
+<p:sldLayout xmlns:a="http://schemas.openxmlformats.org/drawingml/2006/main" xmlns:r="http://schemas.openxmlformats.org/officeDocument/2006/relationships" xmlns:p="http://schemas.openxmlformats.org/presentationml/2006/main" showMasterPhAnim="0" type="vertTx" preserve="1" userDrawn="1">
+  <p:cSld name="标题和竖排文字">
     <p:spTree>
       <p:nvGrpSpPr>
         <p:cNvPr id="1" name=""/>
         <p:cNvGrpSpPr/>
         <p:nvPr/>
       </p:nvGrpSpPr>
-      <p:grpSpPr>
+      <p:grpSpPr bwMode="auto">
         <a:xfrm>
           <a:off x="0" y="0"/>
           <a:ext cx="0" cy="0"/>
@@ -771,7 +811,7 @@
       </p:grpSpPr>
       <p:sp>
         <p:nvSpPr>
-          <p:cNvPr id="2" name="Title 1"/>
+          <p:cNvPr id="234246294" name="标题 1"/>
           <p:cNvSpPr>
             <a:spLocks noGrp="1"/>
           </p:cNvSpPr>
@@ -779,22 +819,24 @@
             <p:ph type="title"/>
           </p:nvPr>
         </p:nvSpPr>
-        <p:spPr/>
-        <p:txBody>
-          <a:bodyPr/>
-          <a:lstStyle/>
-          <a:p>
-            <a:r>
-              <a:rPr lang="zh-CN" smtClean="0"/>
-              <a:t>Click to edit Master title style</a:t>
-            </a:r>
-            <a:endParaRPr lang="zh-CN" dirty="0"/>
-          </a:p>
-        </p:txBody>
-      </p:sp>
-      <p:sp>
-        <p:nvSpPr>
-          <p:cNvPr id="3" name="Vertical Text Placeholder 2"/>
+        <p:spPr bwMode="auto"/>
+        <p:txBody>
+          <a:bodyPr/>
+          <a:lstStyle/>
+          <a:p>
+            <a:pPr>
+              <a:defRPr/>
+            </a:pPr>
+            <a:r>
+              <a:rPr lang="zh-CN"/>
+              <a:t>单击此处编辑母版标题样式</a:t>
+            </a:r>
+          </a:p>
+        </p:txBody>
+      </p:sp>
+      <p:sp>
+        <p:nvSpPr>
+          <p:cNvPr id="567508664" name="竖排文字占位符 2"/>
           <p:cNvSpPr>
             <a:spLocks noGrp="1"/>
           </p:cNvSpPr>
@@ -802,51 +844,64 @@
             <p:ph type="body" orient="vert" idx="1"/>
           </p:nvPr>
         </p:nvSpPr>
-        <p:spPr/>
+        <p:spPr bwMode="auto"/>
         <p:txBody>
           <a:bodyPr vert="eaVert"/>
           <a:lstStyle/>
           <a:p>
-            <a:pPr lvl="0"/>
-            <a:r>
-              <a:rPr lang="zh-CN" smtClean="0"/>
-              <a:t>Click to edit Master text styles</a:t>
-            </a:r>
-          </a:p>
-          <a:p>
-            <a:pPr lvl="1"/>
-            <a:r>
-              <a:rPr lang="zh-CN" smtClean="0"/>
-              <a:t>Second level</a:t>
-            </a:r>
-          </a:p>
-          <a:p>
-            <a:pPr lvl="2"/>
-            <a:r>
-              <a:rPr lang="zh-CN" smtClean="0"/>
-              <a:t>Third level</a:t>
-            </a:r>
-          </a:p>
-          <a:p>
-            <a:pPr lvl="3"/>
-            <a:r>
-              <a:rPr lang="zh-CN" smtClean="0"/>
-              <a:t>Fourth level</a:t>
-            </a:r>
-          </a:p>
-          <a:p>
-            <a:pPr lvl="4"/>
-            <a:r>
-              <a:rPr lang="zh-CN" smtClean="0"/>
-              <a:t>Fifth level</a:t>
-            </a:r>
-            <a:endParaRPr lang="zh-CN" dirty="0"/>
-          </a:p>
-        </p:txBody>
-      </p:sp>
-      <p:sp>
-        <p:nvSpPr>
-          <p:cNvPr id="4" name="Date Placeholder 3"/>
+            <a:pPr lvl="0">
+              <a:defRPr/>
+            </a:pPr>
+            <a:r>
+              <a:rPr lang="zh-CN"/>
+              <a:t>单击此处编辑母版文本样式</a:t>
+            </a:r>
+            <a:endParaRPr/>
+          </a:p>
+          <a:p>
+            <a:pPr lvl="1">
+              <a:defRPr/>
+            </a:pPr>
+            <a:r>
+              <a:rPr lang="zh-CN"/>
+              <a:t>二级</a:t>
+            </a:r>
+            <a:endParaRPr/>
+          </a:p>
+          <a:p>
+            <a:pPr lvl="2">
+              <a:defRPr/>
+            </a:pPr>
+            <a:r>
+              <a:rPr lang="zh-CN"/>
+              <a:t>三级</a:t>
+            </a:r>
+            <a:endParaRPr/>
+          </a:p>
+          <a:p>
+            <a:pPr lvl="3">
+              <a:defRPr/>
+            </a:pPr>
+            <a:r>
+              <a:rPr lang="zh-CN"/>
+              <a:t>四级</a:t>
+            </a:r>
+            <a:endParaRPr/>
+          </a:p>
+          <a:p>
+            <a:pPr lvl="4">
+              <a:defRPr/>
+            </a:pPr>
+            <a:r>
+              <a:rPr lang="zh-CN"/>
+              <a:t>五级</a:t>
+            </a:r>
+          </a:p>
+        </p:txBody>
+      </p:sp>
+      <p:sp>
+        <p:nvSpPr>
+          <p:cNvPr id="60458396" name="日期占位符 3"/>
           <p:cNvSpPr>
             <a:spLocks noGrp="1"/>
           </p:cNvSpPr>
@@ -854,14 +909,17 @@
             <p:ph type="dt" sz="half" idx="10"/>
           </p:nvPr>
         </p:nvSpPr>
-        <p:spPr/>
-        <p:txBody>
-          <a:bodyPr/>
-          <a:lstStyle/>
-          <a:p>
+        <p:spPr bwMode="auto"/>
+        <p:txBody>
+          <a:bodyPr/>
+          <a:lstStyle/>
+          <a:p>
+            <a:pPr>
+              <a:defRPr/>
+            </a:pPr>
             <a:fld id="{BCC18F51-09EC-435C-A3BA-64A766E099C0}" type="datetimeFigureOut">
-              <a:rPr lang="zh-CN" smtClean="0"/>
-              <a:t>30.10.2013</a:t>
+              <a:rPr lang="en-US" altLang="zh-CN"/>
+              <a:t>2026/4/10</a:t>
             </a:fld>
             <a:endParaRPr lang="zh-CN"/>
           </a:p>
@@ -869,7 +927,7 @@
       </p:sp>
       <p:sp>
         <p:nvSpPr>
-          <p:cNvPr id="5" name="Footer Placeholder 4"/>
+          <p:cNvPr id="146550233" name="页脚占位符 4"/>
           <p:cNvSpPr>
             <a:spLocks noGrp="1"/>
           </p:cNvSpPr>
@@ -877,18 +935,21 @@
             <p:ph type="ftr" sz="quarter" idx="11"/>
           </p:nvPr>
         </p:nvSpPr>
-        <p:spPr/>
-        <p:txBody>
-          <a:bodyPr/>
-          <a:lstStyle/>
-          <a:p>
+        <p:spPr bwMode="auto"/>
+        <p:txBody>
+          <a:bodyPr/>
+          <a:lstStyle/>
+          <a:p>
+            <a:pPr>
+              <a:defRPr/>
+            </a:pPr>
             <a:endParaRPr lang="zh-CN"/>
           </a:p>
         </p:txBody>
       </p:sp>
       <p:sp>
         <p:nvSpPr>
-          <p:cNvPr id="6" name="Slide Number Placeholder 5"/>
+          <p:cNvPr id="1569123788" name="灯片编号占位符 5"/>
           <p:cNvSpPr>
             <a:spLocks noGrp="1"/>
           </p:cNvSpPr>
@@ -896,13 +957,16 @@
             <p:ph type="sldNum" sz="quarter" idx="12"/>
           </p:nvPr>
         </p:nvSpPr>
-        <p:spPr/>
-        <p:txBody>
-          <a:bodyPr/>
-          <a:lstStyle/>
-          <a:p>
+        <p:spPr bwMode="auto"/>
+        <p:txBody>
+          <a:bodyPr/>
+          <a:lstStyle/>
+          <a:p>
+            <a:pPr>
+              <a:defRPr/>
+            </a:pPr>
             <a:fld id="{08395586-F03A-48D1-94DF-16B239DF4FB5}" type="slidenum">
-              <a:rPr lang="zh-CN" smtClean="0"/>
+              <a:rPr lang="zh-CN"/>
               <a:t>‹#›</a:t>
             </a:fld>
             <a:endParaRPr lang="zh-CN"/>
@@ -910,11 +974,6 @@
         </p:txBody>
       </p:sp>
     </p:spTree>
-    <p:extLst>
-      <p:ext uri="{BB962C8B-B14F-4D97-AF65-F5344CB8AC3E}">
-        <p14:creationId xmlns:p14="http://schemas.microsoft.com/office/powerpoint/2010/main" val="2377304659"/>
-      </p:ext>
-    </p:extLst>
   </p:cSld>
   <p:clrMapOvr>
     <a:masterClrMapping/>
@@ -923,15 +982,15 @@
 </file>
 
 <file path=ppt/slideLayouts/slideLayout11.xml><?xml version="1.0" encoding="utf-8"?>
-<p:sldLayout xmlns:a="http://schemas.openxmlformats.org/drawingml/2006/main" xmlns:r="http://schemas.openxmlformats.org/officeDocument/2006/relationships" xmlns:p="http://schemas.openxmlformats.org/presentationml/2006/main" type="vertTitleAndTx" preserve="1">
-  <p:cSld name="Vertical Title and Text">
+<p:sldLayout xmlns:a="http://schemas.openxmlformats.org/drawingml/2006/main" xmlns:r="http://schemas.openxmlformats.org/officeDocument/2006/relationships" xmlns:p="http://schemas.openxmlformats.org/presentationml/2006/main" showMasterPhAnim="0" type="vertTitleAndTx" preserve="1" userDrawn="1">
+  <p:cSld name="竖排标题与文本">
     <p:spTree>
       <p:nvGrpSpPr>
         <p:cNvPr id="1" name=""/>
         <p:cNvGrpSpPr/>
         <p:nvPr/>
       </p:nvGrpSpPr>
-      <p:grpSpPr>
+      <p:grpSpPr bwMode="auto">
         <a:xfrm>
           <a:off x="0" y="0"/>
           <a:ext cx="0" cy="0"/>
@@ -941,7 +1000,7 @@
       </p:grpSpPr>
       <p:sp>
         <p:nvSpPr>
-          <p:cNvPr id="2" name="Vertical Title 1"/>
+          <p:cNvPr id="1111794236" name="竖排标题 1"/>
           <p:cNvSpPr>
             <a:spLocks noGrp="1"/>
           </p:cNvSpPr>
@@ -949,7 +1008,7 @@
             <p:ph type="title" orient="vert"/>
           </p:nvPr>
         </p:nvSpPr>
-        <p:spPr>
+        <p:spPr bwMode="auto">
           <a:xfrm>
             <a:off x="8724900" y="365125"/>
             <a:ext cx="2628900" cy="5811838"/>
@@ -959,17 +1018,19 @@
           <a:bodyPr vert="eaVert"/>
           <a:lstStyle/>
           <a:p>
-            <a:r>
-              <a:rPr lang="zh-CN" smtClean="0"/>
-              <a:t>Click to edit Master title style</a:t>
-            </a:r>
-            <a:endParaRPr lang="zh-CN" dirty="0"/>
-          </a:p>
-        </p:txBody>
-      </p:sp>
-      <p:sp>
-        <p:nvSpPr>
-          <p:cNvPr id="3" name="Vertical Text Placeholder 2"/>
+            <a:pPr>
+              <a:defRPr/>
+            </a:pPr>
+            <a:r>
+              <a:rPr lang="zh-CN"/>
+              <a:t>单击此处编辑母版标题样式</a:t>
+            </a:r>
+          </a:p>
+        </p:txBody>
+      </p:sp>
+      <p:sp>
+        <p:nvSpPr>
+          <p:cNvPr id="2026232647" name="竖排文字占位符 2"/>
           <p:cNvSpPr>
             <a:spLocks noGrp="1"/>
           </p:cNvSpPr>
@@ -977,7 +1038,7 @@
             <p:ph type="body" orient="vert" idx="1"/>
           </p:nvPr>
         </p:nvSpPr>
-        <p:spPr>
+        <p:spPr bwMode="auto">
           <a:xfrm>
             <a:off x="838200" y="365125"/>
             <a:ext cx="7734300" cy="5811838"/>
@@ -987,46 +1048,59 @@
           <a:bodyPr vert="eaVert"/>
           <a:lstStyle/>
           <a:p>
-            <a:pPr lvl="0"/>
-            <a:r>
-              <a:rPr lang="zh-CN" smtClean="0"/>
-              <a:t>Click to edit Master text styles</a:t>
-            </a:r>
-          </a:p>
-          <a:p>
-            <a:pPr lvl="1"/>
-            <a:r>
-              <a:rPr lang="zh-CN" smtClean="0"/>
-              <a:t>Second level</a:t>
-            </a:r>
-          </a:p>
-          <a:p>
-            <a:pPr lvl="2"/>
-            <a:r>
-              <a:rPr lang="zh-CN" smtClean="0"/>
-              <a:t>Third level</a:t>
-            </a:r>
-          </a:p>
-          <a:p>
-            <a:pPr lvl="3"/>
-            <a:r>
-              <a:rPr lang="zh-CN" smtClean="0"/>
-              <a:t>Fourth level</a:t>
-            </a:r>
-          </a:p>
-          <a:p>
-            <a:pPr lvl="4"/>
-            <a:r>
-              <a:rPr lang="zh-CN" smtClean="0"/>
-              <a:t>Fifth level</a:t>
-            </a:r>
-            <a:endParaRPr lang="zh-CN" dirty="0"/>
-          </a:p>
-        </p:txBody>
-      </p:sp>
-      <p:sp>
-        <p:nvSpPr>
-          <p:cNvPr id="4" name="Date Placeholder 3"/>
+            <a:pPr lvl="0">
+              <a:defRPr/>
+            </a:pPr>
+            <a:r>
+              <a:rPr lang="zh-CN"/>
+              <a:t>单击此处编辑母版文本样式</a:t>
+            </a:r>
+            <a:endParaRPr/>
+          </a:p>
+          <a:p>
+            <a:pPr lvl="1">
+              <a:defRPr/>
+            </a:pPr>
+            <a:r>
+              <a:rPr lang="zh-CN"/>
+              <a:t>二级</a:t>
+            </a:r>
+            <a:endParaRPr/>
+          </a:p>
+          <a:p>
+            <a:pPr lvl="2">
+              <a:defRPr/>
+            </a:pPr>
+            <a:r>
+              <a:rPr lang="zh-CN"/>
+              <a:t>三级</a:t>
+            </a:r>
+            <a:endParaRPr/>
+          </a:p>
+          <a:p>
+            <a:pPr lvl="3">
+              <a:defRPr/>
+            </a:pPr>
+            <a:r>
+              <a:rPr lang="zh-CN"/>
+              <a:t>四级</a:t>
+            </a:r>
+            <a:endParaRPr/>
+          </a:p>
+          <a:p>
+            <a:pPr lvl="4">
+              <a:defRPr/>
+            </a:pPr>
+            <a:r>
+              <a:rPr lang="zh-CN"/>
+              <a:t>五级</a:t>
+            </a:r>
+          </a:p>
+        </p:txBody>
+      </p:sp>
+      <p:sp>
+        <p:nvSpPr>
+          <p:cNvPr id="402725679" name="日期占位符 3"/>
           <p:cNvSpPr>
             <a:spLocks noGrp="1"/>
           </p:cNvSpPr>
@@ -1034,14 +1108,17 @@
             <p:ph type="dt" sz="half" idx="10"/>
           </p:nvPr>
         </p:nvSpPr>
-        <p:spPr/>
-        <p:txBody>
-          <a:bodyPr/>
-          <a:lstStyle/>
-          <a:p>
+        <p:spPr bwMode="auto"/>
+        <p:txBody>
+          <a:bodyPr/>
+          <a:lstStyle/>
+          <a:p>
+            <a:pPr>
+              <a:defRPr/>
+            </a:pPr>
             <a:fld id="{BCC18F51-09EC-435C-A3BA-64A766E099C0}" type="datetimeFigureOut">
-              <a:rPr lang="zh-CN" smtClean="0"/>
-              <a:t>30.10.2013</a:t>
+              <a:rPr lang="en-US" altLang="zh-CN"/>
+              <a:t>2026/4/10</a:t>
             </a:fld>
             <a:endParaRPr lang="zh-CN"/>
           </a:p>
@@ -1049,7 +1126,7 @@
       </p:sp>
       <p:sp>
         <p:nvSpPr>
-          <p:cNvPr id="5" name="Footer Placeholder 4"/>
+          <p:cNvPr id="977209078" name="页脚占位符 4"/>
           <p:cNvSpPr>
             <a:spLocks noGrp="1"/>
           </p:cNvSpPr>
@@ -1057,18 +1134,21 @@
             <p:ph type="ftr" sz="quarter" idx="11"/>
           </p:nvPr>
         </p:nvSpPr>
-        <p:spPr/>
-        <p:txBody>
-          <a:bodyPr/>
-          <a:lstStyle/>
-          <a:p>
+        <p:spPr bwMode="auto"/>
+        <p:txBody>
+          <a:bodyPr/>
+          <a:lstStyle/>
+          <a:p>
+            <a:pPr>
+              <a:defRPr/>
+            </a:pPr>
             <a:endParaRPr lang="zh-CN"/>
           </a:p>
         </p:txBody>
       </p:sp>
       <p:sp>
         <p:nvSpPr>
-          <p:cNvPr id="6" name="Slide Number Placeholder 5"/>
+          <p:cNvPr id="431157410" name="灯片编号占位符 5"/>
           <p:cNvSpPr>
             <a:spLocks noGrp="1"/>
           </p:cNvSpPr>
@@ -1076,13 +1156,16 @@
             <p:ph type="sldNum" sz="quarter" idx="12"/>
           </p:nvPr>
         </p:nvSpPr>
-        <p:spPr/>
-        <p:txBody>
-          <a:bodyPr/>
-          <a:lstStyle/>
-          <a:p>
+        <p:spPr bwMode="auto"/>
+        <p:txBody>
+          <a:bodyPr/>
+          <a:lstStyle/>
+          <a:p>
+            <a:pPr>
+              <a:defRPr/>
+            </a:pPr>
             <a:fld id="{08395586-F03A-48D1-94DF-16B239DF4FB5}" type="slidenum">
-              <a:rPr lang="zh-CN" smtClean="0"/>
+              <a:rPr lang="zh-CN"/>
               <a:t>‹#›</a:t>
             </a:fld>
             <a:endParaRPr lang="zh-CN"/>
@@ -1090,11 +1173,6 @@
         </p:txBody>
       </p:sp>
     </p:spTree>
-    <p:extLst>
-      <p:ext uri="{BB962C8B-B14F-4D97-AF65-F5344CB8AC3E}">
-        <p14:creationId xmlns:p14="http://schemas.microsoft.com/office/powerpoint/2010/main" val="4161801277"/>
-      </p:ext>
-    </p:extLst>
   </p:cSld>
   <p:clrMapOvr>
     <a:masterClrMapping/>
@@ -1103,15 +1181,15 @@
 </file>
 
 <file path=ppt/slideLayouts/slideLayout2.xml><?xml version="1.0" encoding="utf-8"?>
-<p:sldLayout xmlns:a="http://schemas.openxmlformats.org/drawingml/2006/main" xmlns:r="http://schemas.openxmlformats.org/officeDocument/2006/relationships" xmlns:p="http://schemas.openxmlformats.org/presentationml/2006/main" type="obj" preserve="1">
-  <p:cSld name="Title and Content">
+<p:sldLayout xmlns:a="http://schemas.openxmlformats.org/drawingml/2006/main" xmlns:r="http://schemas.openxmlformats.org/officeDocument/2006/relationships" xmlns:p="http://schemas.openxmlformats.org/presentationml/2006/main" showMasterPhAnim="0" type="obj" preserve="1" userDrawn="1">
+  <p:cSld name="标题和内容">
     <p:spTree>
       <p:nvGrpSpPr>
         <p:cNvPr id="1" name=""/>
         <p:cNvGrpSpPr/>
         <p:nvPr/>
       </p:nvGrpSpPr>
-      <p:grpSpPr>
+      <p:grpSpPr bwMode="auto">
         <a:xfrm>
           <a:off x="0" y="0"/>
           <a:ext cx="0" cy="0"/>
@@ -1121,7 +1199,7 @@
       </p:grpSpPr>
       <p:sp>
         <p:nvSpPr>
-          <p:cNvPr id="2" name="Title 1"/>
+          <p:cNvPr id="421125721" name="标题 1"/>
           <p:cNvSpPr>
             <a:spLocks noGrp="1"/>
           </p:cNvSpPr>
@@ -1129,22 +1207,24 @@
             <p:ph type="title"/>
           </p:nvPr>
         </p:nvSpPr>
-        <p:spPr/>
-        <p:txBody>
-          <a:bodyPr/>
-          <a:lstStyle/>
-          <a:p>
-            <a:r>
-              <a:rPr lang="zh-CN" smtClean="0"/>
-              <a:t>Click to edit Master title style</a:t>
-            </a:r>
-            <a:endParaRPr lang="zh-CN" dirty="0"/>
-          </a:p>
-        </p:txBody>
-      </p:sp>
-      <p:sp>
-        <p:nvSpPr>
-          <p:cNvPr id="3" name="Content Placeholder 2"/>
+        <p:spPr bwMode="auto"/>
+        <p:txBody>
+          <a:bodyPr/>
+          <a:lstStyle/>
+          <a:p>
+            <a:pPr>
+              <a:defRPr/>
+            </a:pPr>
+            <a:r>
+              <a:rPr lang="zh-CN"/>
+              <a:t>单击此处编辑母版标题样式</a:t>
+            </a:r>
+          </a:p>
+        </p:txBody>
+      </p:sp>
+      <p:sp>
+        <p:nvSpPr>
+          <p:cNvPr id="665012651" name="内容占位符 2"/>
           <p:cNvSpPr>
             <a:spLocks noGrp="1"/>
           </p:cNvSpPr>
@@ -1152,51 +1232,64 @@
             <p:ph idx="1"/>
           </p:nvPr>
         </p:nvSpPr>
-        <p:spPr/>
-        <p:txBody>
-          <a:bodyPr/>
-          <a:lstStyle/>
-          <a:p>
-            <a:pPr lvl="0"/>
-            <a:r>
-              <a:rPr lang="zh-CN" smtClean="0"/>
-              <a:t>Click to edit Master text styles</a:t>
-            </a:r>
-          </a:p>
-          <a:p>
-            <a:pPr lvl="1"/>
-            <a:r>
-              <a:rPr lang="zh-CN" smtClean="0"/>
-              <a:t>Second level</a:t>
-            </a:r>
-          </a:p>
-          <a:p>
-            <a:pPr lvl="2"/>
-            <a:r>
-              <a:rPr lang="zh-CN" smtClean="0"/>
-              <a:t>Third level</a:t>
-            </a:r>
-          </a:p>
-          <a:p>
-            <a:pPr lvl="3"/>
-            <a:r>
-              <a:rPr lang="zh-CN" smtClean="0"/>
-              <a:t>Fourth level</a:t>
-            </a:r>
-          </a:p>
-          <a:p>
-            <a:pPr lvl="4"/>
-            <a:r>
-              <a:rPr lang="zh-CN" smtClean="0"/>
-              <a:t>Fifth level</a:t>
-            </a:r>
-            <a:endParaRPr lang="zh-CN" dirty="0"/>
-          </a:p>
-        </p:txBody>
-      </p:sp>
-      <p:sp>
-        <p:nvSpPr>
-          <p:cNvPr id="4" name="Date Placeholder 3"/>
+        <p:spPr bwMode="auto"/>
+        <p:txBody>
+          <a:bodyPr/>
+          <a:lstStyle/>
+          <a:p>
+            <a:pPr lvl="0">
+              <a:defRPr/>
+            </a:pPr>
+            <a:r>
+              <a:rPr lang="zh-CN"/>
+              <a:t>单击此处编辑母版文本样式</a:t>
+            </a:r>
+            <a:endParaRPr/>
+          </a:p>
+          <a:p>
+            <a:pPr lvl="1">
+              <a:defRPr/>
+            </a:pPr>
+            <a:r>
+              <a:rPr lang="zh-CN"/>
+              <a:t>二级</a:t>
+            </a:r>
+            <a:endParaRPr/>
+          </a:p>
+          <a:p>
+            <a:pPr lvl="2">
+              <a:defRPr/>
+            </a:pPr>
+            <a:r>
+              <a:rPr lang="zh-CN"/>
+              <a:t>三级</a:t>
+            </a:r>
+            <a:endParaRPr/>
+          </a:p>
+          <a:p>
+            <a:pPr lvl="3">
+              <a:defRPr/>
+            </a:pPr>
+            <a:r>
+              <a:rPr lang="zh-CN"/>
+              <a:t>四级</a:t>
+            </a:r>
+            <a:endParaRPr/>
+          </a:p>
+          <a:p>
+            <a:pPr lvl="4">
+              <a:defRPr/>
+            </a:pPr>
+            <a:r>
+              <a:rPr lang="zh-CN"/>
+              <a:t>五级</a:t>
+            </a:r>
+          </a:p>
+        </p:txBody>
+      </p:sp>
+      <p:sp>
+        <p:nvSpPr>
+          <p:cNvPr id="123473562" name="日期占位符 3"/>
           <p:cNvSpPr>
             <a:spLocks noGrp="1"/>
           </p:cNvSpPr>
@@ -1204,14 +1297,17 @@
             <p:ph type="dt" sz="half" idx="10"/>
           </p:nvPr>
         </p:nvSpPr>
-        <p:spPr/>
-        <p:txBody>
-          <a:bodyPr/>
-          <a:lstStyle/>
-          <a:p>
+        <p:spPr bwMode="auto"/>
+        <p:txBody>
+          <a:bodyPr/>
+          <a:lstStyle/>
+          <a:p>
+            <a:pPr>
+              <a:defRPr/>
+            </a:pPr>
             <a:fld id="{BCC18F51-09EC-435C-A3BA-64A766E099C0}" type="datetimeFigureOut">
-              <a:rPr lang="zh-CN" smtClean="0"/>
-              <a:t>30.10.2013</a:t>
+              <a:rPr lang="en-US" altLang="zh-CN"/>
+              <a:t>2026/4/10</a:t>
             </a:fld>
             <a:endParaRPr lang="zh-CN"/>
           </a:p>
@@ -1219,7 +1315,7 @@
       </p:sp>
       <p:sp>
         <p:nvSpPr>
-          <p:cNvPr id="5" name="Footer Placeholder 4"/>
+          <p:cNvPr id="207730871" name="页脚占位符 4"/>
           <p:cNvSpPr>
             <a:spLocks noGrp="1"/>
           </p:cNvSpPr>
@@ -1227,18 +1323,21 @@
             <p:ph type="ftr" sz="quarter" idx="11"/>
           </p:nvPr>
         </p:nvSpPr>
-        <p:spPr/>
-        <p:txBody>
-          <a:bodyPr/>
-          <a:lstStyle/>
-          <a:p>
+        <p:spPr bwMode="auto"/>
+        <p:txBody>
+          <a:bodyPr/>
+          <a:lstStyle/>
+          <a:p>
+            <a:pPr>
+              <a:defRPr/>
+            </a:pPr>
             <a:endParaRPr lang="zh-CN"/>
           </a:p>
         </p:txBody>
       </p:sp>
       <p:sp>
         <p:nvSpPr>
-          <p:cNvPr id="6" name="Slide Number Placeholder 5"/>
+          <p:cNvPr id="1513176787" name="灯片编号占位符 5"/>
           <p:cNvSpPr>
             <a:spLocks noGrp="1"/>
           </p:cNvSpPr>
@@ -1246,13 +1345,16 @@
             <p:ph type="sldNum" sz="quarter" idx="12"/>
           </p:nvPr>
         </p:nvSpPr>
-        <p:spPr/>
-        <p:txBody>
-          <a:bodyPr/>
-          <a:lstStyle/>
-          <a:p>
+        <p:spPr bwMode="auto"/>
+        <p:txBody>
+          <a:bodyPr/>
+          <a:lstStyle/>
+          <a:p>
+            <a:pPr>
+              <a:defRPr/>
+            </a:pPr>
             <a:fld id="{08395586-F03A-48D1-94DF-16B239DF4FB5}" type="slidenum">
-              <a:rPr lang="zh-CN" smtClean="0"/>
+              <a:rPr lang="zh-CN"/>
               <a:t>‹#›</a:t>
             </a:fld>
             <a:endParaRPr lang="zh-CN"/>
@@ -1260,11 +1362,6 @@
         </p:txBody>
       </p:sp>
     </p:spTree>
-    <p:extLst>
-      <p:ext uri="{BB962C8B-B14F-4D97-AF65-F5344CB8AC3E}">
-        <p14:creationId xmlns:p14="http://schemas.microsoft.com/office/powerpoint/2010/main" val="2960619921"/>
-      </p:ext>
-    </p:extLst>
   </p:cSld>
   <p:clrMapOvr>
     <a:masterClrMapping/>
@@ -1273,15 +1370,15 @@
 </file>
 
 <file path=ppt/slideLayouts/slideLayout3.xml><?xml version="1.0" encoding="utf-8"?>
-<p:sldLayout xmlns:a="http://schemas.openxmlformats.org/drawingml/2006/main" xmlns:r="http://schemas.openxmlformats.org/officeDocument/2006/relationships" xmlns:p="http://schemas.openxmlformats.org/presentationml/2006/main" type="secHead" preserve="1">
-  <p:cSld name="Section Header">
+<p:sldLayout xmlns:a="http://schemas.openxmlformats.org/drawingml/2006/main" xmlns:r="http://schemas.openxmlformats.org/officeDocument/2006/relationships" xmlns:p="http://schemas.openxmlformats.org/presentationml/2006/main" showMasterPhAnim="0" type="secHead" preserve="1" userDrawn="1">
+  <p:cSld name="节标题">
     <p:spTree>
       <p:nvGrpSpPr>
         <p:cNvPr id="1" name=""/>
         <p:cNvGrpSpPr/>
         <p:nvPr/>
       </p:nvGrpSpPr>
-      <p:grpSpPr>
+      <p:grpSpPr bwMode="auto">
         <a:xfrm>
           <a:off x="0" y="0"/>
           <a:ext cx="0" cy="0"/>
@@ -1291,7 +1388,7 @@
       </p:grpSpPr>
       <p:sp>
         <p:nvSpPr>
-          <p:cNvPr id="2" name="Title 1"/>
+          <p:cNvPr id="542182457" name="标题 1"/>
           <p:cNvSpPr>
             <a:spLocks noGrp="1"/>
           </p:cNvSpPr>
@@ -1299,7 +1396,7 @@
             <p:ph type="title"/>
           </p:nvPr>
         </p:nvSpPr>
-        <p:spPr>
+        <p:spPr bwMode="auto">
           <a:xfrm>
             <a:off x="831850" y="1709738"/>
             <a:ext cx="10515600" cy="2852737"/>
@@ -1313,17 +1410,19 @@
             </a:lvl1pPr>
           </a:lstStyle>
           <a:p>
-            <a:r>
-              <a:rPr lang="zh-CN" smtClean="0"/>
-              <a:t>Click to edit Master title style</a:t>
-            </a:r>
-            <a:endParaRPr lang="zh-CN" dirty="0"/>
-          </a:p>
-        </p:txBody>
-      </p:sp>
-      <p:sp>
-        <p:nvSpPr>
-          <p:cNvPr id="3" name="Text Placeholder 2"/>
+            <a:pPr>
+              <a:defRPr/>
+            </a:pPr>
+            <a:r>
+              <a:rPr lang="zh-CN"/>
+              <a:t>单击此处编辑母版标题样式</a:t>
+            </a:r>
+          </a:p>
+        </p:txBody>
+      </p:sp>
+      <p:sp>
+        <p:nvSpPr>
+          <p:cNvPr id="1830510895" name="文本占位符 2"/>
           <p:cNvSpPr>
             <a:spLocks noGrp="1"/>
           </p:cNvSpPr>
@@ -1331,7 +1430,7 @@
             <p:ph type="body" idx="1"/>
           </p:nvPr>
         </p:nvSpPr>
-        <p:spPr>
+        <p:spPr bwMode="auto">
           <a:xfrm>
             <a:off x="831850" y="4589463"/>
             <a:ext cx="10515600" cy="1500187"/>
@@ -1432,17 +1531,20 @@
             </a:lvl9pPr>
           </a:lstStyle>
           <a:p>
-            <a:pPr lvl="0"/>
-            <a:r>
-              <a:rPr lang="zh-CN" smtClean="0"/>
-              <a:t>Click to edit Master text styles</a:t>
-            </a:r>
-          </a:p>
-        </p:txBody>
-      </p:sp>
-      <p:sp>
-        <p:nvSpPr>
-          <p:cNvPr id="4" name="Date Placeholder 3"/>
+            <a:pPr lvl="0">
+              <a:defRPr/>
+            </a:pPr>
+            <a:r>
+              <a:rPr lang="zh-CN"/>
+              <a:t>单击此处编辑母版文本样式</a:t>
+            </a:r>
+            <a:endParaRPr/>
+          </a:p>
+        </p:txBody>
+      </p:sp>
+      <p:sp>
+        <p:nvSpPr>
+          <p:cNvPr id="1028891342" name="日期占位符 3"/>
           <p:cNvSpPr>
             <a:spLocks noGrp="1"/>
           </p:cNvSpPr>
@@ -1450,14 +1552,17 @@
             <p:ph type="dt" sz="half" idx="10"/>
           </p:nvPr>
         </p:nvSpPr>
-        <p:spPr/>
-        <p:txBody>
-          <a:bodyPr/>
-          <a:lstStyle/>
-          <a:p>
+        <p:spPr bwMode="auto"/>
+        <p:txBody>
+          <a:bodyPr/>
+          <a:lstStyle/>
+          <a:p>
+            <a:pPr>
+              <a:defRPr/>
+            </a:pPr>
             <a:fld id="{BCC18F51-09EC-435C-A3BA-64A766E099C0}" type="datetimeFigureOut">
-              <a:rPr lang="zh-CN" smtClean="0"/>
-              <a:t>30.10.2013</a:t>
+              <a:rPr lang="en-US" altLang="zh-CN"/>
+              <a:t>2026/4/10</a:t>
             </a:fld>
             <a:endParaRPr lang="zh-CN"/>
           </a:p>
@@ -1465,7 +1570,7 @@
       </p:sp>
       <p:sp>
         <p:nvSpPr>
-          <p:cNvPr id="5" name="Footer Placeholder 4"/>
+          <p:cNvPr id="83429500" name="页脚占位符 4"/>
           <p:cNvSpPr>
             <a:spLocks noGrp="1"/>
           </p:cNvSpPr>
@@ -1473,18 +1578,21 @@
             <p:ph type="ftr" sz="quarter" idx="11"/>
           </p:nvPr>
         </p:nvSpPr>
-        <p:spPr/>
-        <p:txBody>
-          <a:bodyPr/>
-          <a:lstStyle/>
-          <a:p>
+        <p:spPr bwMode="auto"/>
+        <p:txBody>
+          <a:bodyPr/>
+          <a:lstStyle/>
+          <a:p>
+            <a:pPr>
+              <a:defRPr/>
+            </a:pPr>
             <a:endParaRPr lang="zh-CN"/>
           </a:p>
         </p:txBody>
       </p:sp>
       <p:sp>
         <p:nvSpPr>
-          <p:cNvPr id="6" name="Slide Number Placeholder 5"/>
+          <p:cNvPr id="281999118" name="Slide Number Placeholder 5"/>
           <p:cNvSpPr>
             <a:spLocks noGrp="1"/>
           </p:cNvSpPr>
@@ -1492,13 +1600,16 @@
             <p:ph type="sldNum" sz="quarter" idx="12"/>
           </p:nvPr>
         </p:nvSpPr>
-        <p:spPr/>
-        <p:txBody>
-          <a:bodyPr/>
-          <a:lstStyle/>
-          <a:p>
+        <p:spPr bwMode="auto"/>
+        <p:txBody>
+          <a:bodyPr/>
+          <a:lstStyle/>
+          <a:p>
+            <a:pPr>
+              <a:defRPr/>
+            </a:pPr>
             <a:fld id="{08395586-F03A-48D1-94DF-16B239DF4FB5}" type="slidenum">
-              <a:rPr lang="zh-CN" smtClean="0"/>
+              <a:rPr lang="zh-CN"/>
               <a:t>‹#›</a:t>
             </a:fld>
             <a:endParaRPr lang="zh-CN"/>
@@ -1506,11 +1617,6 @@
         </p:txBody>
       </p:sp>
     </p:spTree>
-    <p:extLst>
-      <p:ext uri="{BB962C8B-B14F-4D97-AF65-F5344CB8AC3E}">
-        <p14:creationId xmlns:p14="http://schemas.microsoft.com/office/powerpoint/2010/main" val="2072125890"/>
-      </p:ext>
-    </p:extLst>
   </p:cSld>
   <p:clrMapOvr>
     <a:masterClrMapping/>
@@ -1519,15 +1625,15 @@
 </file>
 
 <file path=ppt/slideLayouts/slideLayout4.xml><?xml version="1.0" encoding="utf-8"?>
-<p:sldLayout xmlns:a="http://schemas.openxmlformats.org/drawingml/2006/main" xmlns:r="http://schemas.openxmlformats.org/officeDocument/2006/relationships" xmlns:p="http://schemas.openxmlformats.org/presentationml/2006/main" type="twoObj" preserve="1">
-  <p:cSld name="Two Content">
+<p:sldLayout xmlns:a="http://schemas.openxmlformats.org/drawingml/2006/main" xmlns:r="http://schemas.openxmlformats.org/officeDocument/2006/relationships" xmlns:p="http://schemas.openxmlformats.org/presentationml/2006/main" showMasterPhAnim="0" type="twoObj" preserve="1" userDrawn="1">
+  <p:cSld name="两栏内容">
     <p:spTree>
       <p:nvGrpSpPr>
         <p:cNvPr id="1" name=""/>
         <p:cNvGrpSpPr/>
         <p:nvPr/>
       </p:nvGrpSpPr>
-      <p:grpSpPr>
+      <p:grpSpPr bwMode="auto">
         <a:xfrm>
           <a:off x="0" y="0"/>
           <a:ext cx="0" cy="0"/>
@@ -1537,7 +1643,7 @@
       </p:grpSpPr>
       <p:sp>
         <p:nvSpPr>
-          <p:cNvPr id="2" name="Title 1"/>
+          <p:cNvPr id="1628266987" name="标题 1"/>
           <p:cNvSpPr>
             <a:spLocks noGrp="1"/>
           </p:cNvSpPr>
@@ -1545,22 +1651,24 @@
             <p:ph type="title"/>
           </p:nvPr>
         </p:nvSpPr>
-        <p:spPr/>
-        <p:txBody>
-          <a:bodyPr/>
-          <a:lstStyle/>
-          <a:p>
-            <a:r>
-              <a:rPr lang="zh-CN" smtClean="0"/>
-              <a:t>Click to edit Master title style</a:t>
-            </a:r>
-            <a:endParaRPr lang="zh-CN" dirty="0"/>
-          </a:p>
-        </p:txBody>
-      </p:sp>
-      <p:sp>
-        <p:nvSpPr>
-          <p:cNvPr id="3" name="Content Placeholder 2"/>
+        <p:spPr bwMode="auto"/>
+        <p:txBody>
+          <a:bodyPr/>
+          <a:lstStyle/>
+          <a:p>
+            <a:pPr>
+              <a:defRPr/>
+            </a:pPr>
+            <a:r>
+              <a:rPr lang="zh-CN"/>
+              <a:t>单击此处编辑母版标题样式</a:t>
+            </a:r>
+          </a:p>
+        </p:txBody>
+      </p:sp>
+      <p:sp>
+        <p:nvSpPr>
+          <p:cNvPr id="1809361996" name="内容占位符 2"/>
           <p:cNvSpPr>
             <a:spLocks noGrp="1"/>
           </p:cNvSpPr>
@@ -1568,7 +1676,7 @@
             <p:ph sz="half" idx="1"/>
           </p:nvPr>
         </p:nvSpPr>
-        <p:spPr>
+        <p:spPr bwMode="auto">
           <a:xfrm>
             <a:off x="838200" y="1825625"/>
             <a:ext cx="5181600" cy="4351338"/>
@@ -1578,46 +1686,59 @@
           <a:bodyPr/>
           <a:lstStyle/>
           <a:p>
-            <a:pPr lvl="0"/>
-            <a:r>
-              <a:rPr lang="zh-CN" smtClean="0"/>
-              <a:t>Click to edit Master text styles</a:t>
-            </a:r>
-          </a:p>
-          <a:p>
-            <a:pPr lvl="1"/>
-            <a:r>
-              <a:rPr lang="zh-CN" smtClean="0"/>
-              <a:t>Second level</a:t>
-            </a:r>
-          </a:p>
-          <a:p>
-            <a:pPr lvl="2"/>
-            <a:r>
-              <a:rPr lang="zh-CN" smtClean="0"/>
-              <a:t>Third level</a:t>
-            </a:r>
-          </a:p>
-          <a:p>
-            <a:pPr lvl="3"/>
-            <a:r>
-              <a:rPr lang="zh-CN" smtClean="0"/>
-              <a:t>Fourth level</a:t>
-            </a:r>
-          </a:p>
-          <a:p>
-            <a:pPr lvl="4"/>
-            <a:r>
-              <a:rPr lang="zh-CN" smtClean="0"/>
-              <a:t>Fifth level</a:t>
-            </a:r>
-            <a:endParaRPr lang="zh-CN" dirty="0"/>
-          </a:p>
-        </p:txBody>
-      </p:sp>
-      <p:sp>
-        <p:nvSpPr>
-          <p:cNvPr id="4" name="Content Placeholder 3"/>
+            <a:pPr lvl="0">
+              <a:defRPr/>
+            </a:pPr>
+            <a:r>
+              <a:rPr lang="zh-CN"/>
+              <a:t>单击此处编辑母版文本样式</a:t>
+            </a:r>
+            <a:endParaRPr/>
+          </a:p>
+          <a:p>
+            <a:pPr lvl="1">
+              <a:defRPr/>
+            </a:pPr>
+            <a:r>
+              <a:rPr lang="zh-CN"/>
+              <a:t>二级</a:t>
+            </a:r>
+            <a:endParaRPr/>
+          </a:p>
+          <a:p>
+            <a:pPr lvl="2">
+              <a:defRPr/>
+            </a:pPr>
+            <a:r>
+              <a:rPr lang="zh-CN"/>
+              <a:t>三级</a:t>
+            </a:r>
+            <a:endParaRPr/>
+          </a:p>
+          <a:p>
+            <a:pPr lvl="3">
+              <a:defRPr/>
+            </a:pPr>
+            <a:r>
+              <a:rPr lang="zh-CN"/>
+              <a:t>四级</a:t>
+            </a:r>
+            <a:endParaRPr/>
+          </a:p>
+          <a:p>
+            <a:pPr lvl="4">
+              <a:defRPr/>
+            </a:pPr>
+            <a:r>
+              <a:rPr lang="zh-CN"/>
+              <a:t>五级</a:t>
+            </a:r>
+          </a:p>
+        </p:txBody>
+      </p:sp>
+      <p:sp>
+        <p:nvSpPr>
+          <p:cNvPr id="90516450" name="内容占位符 3"/>
           <p:cNvSpPr>
             <a:spLocks noGrp="1"/>
           </p:cNvSpPr>
@@ -1625,7 +1746,7 @@
             <p:ph sz="half" idx="2"/>
           </p:nvPr>
         </p:nvSpPr>
-        <p:spPr>
+        <p:spPr bwMode="auto">
           <a:xfrm>
             <a:off x="6172200" y="1825625"/>
             <a:ext cx="5181600" cy="4351338"/>
@@ -1635,46 +1756,59 @@
           <a:bodyPr/>
           <a:lstStyle/>
           <a:p>
-            <a:pPr lvl="0"/>
-            <a:r>
-              <a:rPr lang="zh-CN" smtClean="0"/>
-              <a:t>Click to edit Master text styles</a:t>
-            </a:r>
-          </a:p>
-          <a:p>
-            <a:pPr lvl="1"/>
-            <a:r>
-              <a:rPr lang="zh-CN" smtClean="0"/>
-              <a:t>Second level</a:t>
-            </a:r>
-          </a:p>
-          <a:p>
-            <a:pPr lvl="2"/>
-            <a:r>
-              <a:rPr lang="zh-CN" smtClean="0"/>
-              <a:t>Third level</a:t>
-            </a:r>
-          </a:p>
-          <a:p>
-            <a:pPr lvl="3"/>
-            <a:r>
-              <a:rPr lang="zh-CN" smtClean="0"/>
-              <a:t>Fourth level</a:t>
-            </a:r>
-          </a:p>
-          <a:p>
-            <a:pPr lvl="4"/>
-            <a:r>
-              <a:rPr lang="zh-CN" smtClean="0"/>
-              <a:t>Fifth level</a:t>
-            </a:r>
-            <a:endParaRPr lang="zh-CN" dirty="0"/>
-          </a:p>
-        </p:txBody>
-      </p:sp>
-      <p:sp>
-        <p:nvSpPr>
-          <p:cNvPr id="5" name="Date Placeholder 4"/>
+            <a:pPr lvl="0">
+              <a:defRPr/>
+            </a:pPr>
+            <a:r>
+              <a:rPr lang="zh-CN"/>
+              <a:t>单击此处编辑母版文本样式</a:t>
+            </a:r>
+            <a:endParaRPr/>
+          </a:p>
+          <a:p>
+            <a:pPr lvl="1">
+              <a:defRPr/>
+            </a:pPr>
+            <a:r>
+              <a:rPr lang="zh-CN"/>
+              <a:t>二级</a:t>
+            </a:r>
+            <a:endParaRPr/>
+          </a:p>
+          <a:p>
+            <a:pPr lvl="2">
+              <a:defRPr/>
+            </a:pPr>
+            <a:r>
+              <a:rPr lang="zh-CN"/>
+              <a:t>三级</a:t>
+            </a:r>
+            <a:endParaRPr/>
+          </a:p>
+          <a:p>
+            <a:pPr lvl="3">
+              <a:defRPr/>
+            </a:pPr>
+            <a:r>
+              <a:rPr lang="zh-CN"/>
+              <a:t>四级</a:t>
+            </a:r>
+            <a:endParaRPr/>
+          </a:p>
+          <a:p>
+            <a:pPr lvl="4">
+              <a:defRPr/>
+            </a:pPr>
+            <a:r>
+              <a:rPr lang="zh-CN"/>
+              <a:t>五级</a:t>
+            </a:r>
+          </a:p>
+        </p:txBody>
+      </p:sp>
+      <p:sp>
+        <p:nvSpPr>
+          <p:cNvPr id="236933850" name="日期占位符 4"/>
           <p:cNvSpPr>
             <a:spLocks noGrp="1"/>
           </p:cNvSpPr>
@@ -1682,14 +1816,17 @@
             <p:ph type="dt" sz="half" idx="10"/>
           </p:nvPr>
         </p:nvSpPr>
-        <p:spPr/>
-        <p:txBody>
-          <a:bodyPr/>
-          <a:lstStyle/>
-          <a:p>
+        <p:spPr bwMode="auto"/>
+        <p:txBody>
+          <a:bodyPr/>
+          <a:lstStyle/>
+          <a:p>
+            <a:pPr>
+              <a:defRPr/>
+            </a:pPr>
             <a:fld id="{BCC18F51-09EC-435C-A3BA-64A766E099C0}" type="datetimeFigureOut">
-              <a:rPr lang="zh-CN" smtClean="0"/>
-              <a:t>30.10.2013</a:t>
+              <a:rPr lang="en-US" altLang="zh-CN"/>
+              <a:t>2026/4/10</a:t>
             </a:fld>
             <a:endParaRPr lang="zh-CN"/>
           </a:p>
@@ -1697,7 +1834,7 @@
       </p:sp>
       <p:sp>
         <p:nvSpPr>
-          <p:cNvPr id="6" name="Footer Placeholder 5"/>
+          <p:cNvPr id="1739630649" name="页脚占位符 5"/>
           <p:cNvSpPr>
             <a:spLocks noGrp="1"/>
           </p:cNvSpPr>
@@ -1705,18 +1842,21 @@
             <p:ph type="ftr" sz="quarter" idx="11"/>
           </p:nvPr>
         </p:nvSpPr>
-        <p:spPr/>
-        <p:txBody>
-          <a:bodyPr/>
-          <a:lstStyle/>
-          <a:p>
+        <p:spPr bwMode="auto"/>
+        <p:txBody>
+          <a:bodyPr/>
+          <a:lstStyle/>
+          <a:p>
+            <a:pPr>
+              <a:defRPr/>
+            </a:pPr>
             <a:endParaRPr lang="zh-CN"/>
           </a:p>
         </p:txBody>
       </p:sp>
       <p:sp>
         <p:nvSpPr>
-          <p:cNvPr id="7" name="Slide Number Placeholder 6"/>
+          <p:cNvPr id="1034111686" name="灯片编号占位符 6"/>
           <p:cNvSpPr>
             <a:spLocks noGrp="1"/>
           </p:cNvSpPr>
@@ -1724,13 +1864,16 @@
             <p:ph type="sldNum" sz="quarter" idx="12"/>
           </p:nvPr>
         </p:nvSpPr>
-        <p:spPr/>
-        <p:txBody>
-          <a:bodyPr/>
-          <a:lstStyle/>
-          <a:p>
+        <p:spPr bwMode="auto"/>
+        <p:txBody>
+          <a:bodyPr/>
+          <a:lstStyle/>
+          <a:p>
+            <a:pPr>
+              <a:defRPr/>
+            </a:pPr>
             <a:fld id="{08395586-F03A-48D1-94DF-16B239DF4FB5}" type="slidenum">
-              <a:rPr lang="zh-CN" smtClean="0"/>
+              <a:rPr lang="zh-CN"/>
               <a:t>‹#›</a:t>
             </a:fld>
             <a:endParaRPr lang="zh-CN"/>
@@ -1738,11 +1881,6 @@
         </p:txBody>
       </p:sp>
     </p:spTree>
-    <p:extLst>
-      <p:ext uri="{BB962C8B-B14F-4D97-AF65-F5344CB8AC3E}">
-        <p14:creationId xmlns:p14="http://schemas.microsoft.com/office/powerpoint/2010/main" val="4243403397"/>
-      </p:ext>
-    </p:extLst>
   </p:cSld>
   <p:clrMapOvr>
     <a:masterClrMapping/>
@@ -1751,15 +1889,15 @@
 </file>
 
 <file path=ppt/slideLayouts/slideLayout5.xml><?xml version="1.0" encoding="utf-8"?>
-<p:sldLayout xmlns:a="http://schemas.openxmlformats.org/drawingml/2006/main" xmlns:r="http://schemas.openxmlformats.org/officeDocument/2006/relationships" xmlns:p="http://schemas.openxmlformats.org/presentationml/2006/main" type="twoTxTwoObj" preserve="1">
-  <p:cSld name="Comparison">
+<p:sldLayout xmlns:a="http://schemas.openxmlformats.org/drawingml/2006/main" xmlns:r="http://schemas.openxmlformats.org/officeDocument/2006/relationships" xmlns:p="http://schemas.openxmlformats.org/presentationml/2006/main" showMasterPhAnim="0" type="twoTxTwoObj" preserve="1" userDrawn="1">
+  <p:cSld name="比较">
     <p:spTree>
       <p:nvGrpSpPr>
         <p:cNvPr id="1" name=""/>
         <p:cNvGrpSpPr/>
         <p:nvPr/>
       </p:nvGrpSpPr>
-      <p:grpSpPr>
+      <p:grpSpPr bwMode="auto">
         <a:xfrm>
           <a:off x="0" y="0"/>
           <a:ext cx="0" cy="0"/>
@@ -1769,7 +1907,7 @@
       </p:grpSpPr>
       <p:sp>
         <p:nvSpPr>
-          <p:cNvPr id="2" name="Title 1"/>
+          <p:cNvPr id="1389875812" name="标题 1"/>
           <p:cNvSpPr>
             <a:spLocks noGrp="1"/>
           </p:cNvSpPr>
@@ -1777,7 +1915,7 @@
             <p:ph type="title"/>
           </p:nvPr>
         </p:nvSpPr>
-        <p:spPr>
+        <p:spPr bwMode="auto">
           <a:xfrm>
             <a:off x="839788" y="365125"/>
             <a:ext cx="10515600" cy="1325563"/>
@@ -1787,17 +1925,19 @@
           <a:bodyPr/>
           <a:lstStyle/>
           <a:p>
-            <a:r>
-              <a:rPr lang="zh-CN" smtClean="0"/>
-              <a:t>Click to edit Master title style</a:t>
-            </a:r>
-            <a:endParaRPr lang="zh-CN" dirty="0"/>
-          </a:p>
-        </p:txBody>
-      </p:sp>
-      <p:sp>
-        <p:nvSpPr>
-          <p:cNvPr id="3" name="Text Placeholder 2"/>
+            <a:pPr>
+              <a:defRPr/>
+            </a:pPr>
+            <a:r>
+              <a:rPr lang="zh-CN"/>
+              <a:t>单击此处编辑母版标题样式</a:t>
+            </a:r>
+          </a:p>
+        </p:txBody>
+      </p:sp>
+      <p:sp>
+        <p:nvSpPr>
+          <p:cNvPr id="265161974" name="文本占位符 2"/>
           <p:cNvSpPr>
             <a:spLocks noGrp="1"/>
           </p:cNvSpPr>
@@ -1805,7 +1945,7 @@
             <p:ph type="body" idx="1"/>
           </p:nvPr>
         </p:nvSpPr>
-        <p:spPr>
+        <p:spPr bwMode="auto">
           <a:xfrm>
             <a:off x="839788" y="1681163"/>
             <a:ext cx="5157787" cy="823912"/>
@@ -1852,17 +1992,20 @@
             </a:lvl9pPr>
           </a:lstStyle>
           <a:p>
-            <a:pPr lvl="0"/>
-            <a:r>
-              <a:rPr lang="zh-CN" smtClean="0"/>
-              <a:t>Click to edit Master text styles</a:t>
-            </a:r>
-          </a:p>
-        </p:txBody>
-      </p:sp>
-      <p:sp>
-        <p:nvSpPr>
-          <p:cNvPr id="4" name="Content Placeholder 3"/>
+            <a:pPr lvl="0">
+              <a:defRPr/>
+            </a:pPr>
+            <a:r>
+              <a:rPr lang="zh-CN"/>
+              <a:t>单击此处编辑母版文本样式</a:t>
+            </a:r>
+            <a:endParaRPr/>
+          </a:p>
+        </p:txBody>
+      </p:sp>
+      <p:sp>
+        <p:nvSpPr>
+          <p:cNvPr id="1854433795" name="内容占位符 3"/>
           <p:cNvSpPr>
             <a:spLocks noGrp="1"/>
           </p:cNvSpPr>
@@ -1870,9 +2013,9 @@
             <p:ph sz="half" idx="2"/>
           </p:nvPr>
         </p:nvSpPr>
-        <p:spPr>
+        <p:spPr bwMode="auto">
           <a:xfrm>
-            <a:off x="839788" y="2505075"/>
+            <a:off x="839788" y="2505074"/>
             <a:ext cx="5157787" cy="3684588"/>
           </a:xfrm>
         </p:spPr>
@@ -1880,46 +2023,59 @@
           <a:bodyPr/>
           <a:lstStyle/>
           <a:p>
-            <a:pPr lvl="0"/>
-            <a:r>
-              <a:rPr lang="zh-CN" smtClean="0"/>
-              <a:t>Click to edit Master text styles</a:t>
-            </a:r>
-          </a:p>
-          <a:p>
-            <a:pPr lvl="1"/>
-            <a:r>
-              <a:rPr lang="zh-CN" smtClean="0"/>
-              <a:t>Second level</a:t>
-            </a:r>
-          </a:p>
-          <a:p>
-            <a:pPr lvl="2"/>
-            <a:r>
-              <a:rPr lang="zh-CN" smtClean="0"/>
-              <a:t>Third level</a:t>
-            </a:r>
-          </a:p>
-          <a:p>
-            <a:pPr lvl="3"/>
-            <a:r>
-              <a:rPr lang="zh-CN" smtClean="0"/>
-              <a:t>Fourth level</a:t>
-            </a:r>
-          </a:p>
-          <a:p>
-            <a:pPr lvl="4"/>
-            <a:r>
-              <a:rPr lang="zh-CN" smtClean="0"/>
-              <a:t>Fifth level</a:t>
-            </a:r>
-            <a:endParaRPr lang="zh-CN" dirty="0"/>
-          </a:p>
-        </p:txBody>
-      </p:sp>
-      <p:sp>
-        <p:nvSpPr>
-          <p:cNvPr id="5" name="Text Placeholder 4"/>
+            <a:pPr lvl="0">
+              <a:defRPr/>
+            </a:pPr>
+            <a:r>
+              <a:rPr lang="zh-CN"/>
+              <a:t>单击此处编辑母版文本样式</a:t>
+            </a:r>
+            <a:endParaRPr/>
+          </a:p>
+          <a:p>
+            <a:pPr lvl="1">
+              <a:defRPr/>
+            </a:pPr>
+            <a:r>
+              <a:rPr lang="zh-CN"/>
+              <a:t>二级</a:t>
+            </a:r>
+            <a:endParaRPr/>
+          </a:p>
+          <a:p>
+            <a:pPr lvl="2">
+              <a:defRPr/>
+            </a:pPr>
+            <a:r>
+              <a:rPr lang="zh-CN"/>
+              <a:t>三级</a:t>
+            </a:r>
+            <a:endParaRPr/>
+          </a:p>
+          <a:p>
+            <a:pPr lvl="3">
+              <a:defRPr/>
+            </a:pPr>
+            <a:r>
+              <a:rPr lang="zh-CN"/>
+              <a:t>四级</a:t>
+            </a:r>
+            <a:endParaRPr/>
+          </a:p>
+          <a:p>
+            <a:pPr lvl="4">
+              <a:defRPr/>
+            </a:pPr>
+            <a:r>
+              <a:rPr lang="zh-CN"/>
+              <a:t>五级</a:t>
+            </a:r>
+          </a:p>
+        </p:txBody>
+      </p:sp>
+      <p:sp>
+        <p:nvSpPr>
+          <p:cNvPr id="21414901" name="文本占位符 4"/>
           <p:cNvSpPr>
             <a:spLocks noGrp="1"/>
           </p:cNvSpPr>
@@ -1927,7 +2083,7 @@
             <p:ph type="body" sz="quarter" idx="3"/>
           </p:nvPr>
         </p:nvSpPr>
-        <p:spPr>
+        <p:spPr bwMode="auto">
           <a:xfrm>
             <a:off x="6172200" y="1681163"/>
             <a:ext cx="5183188" cy="823912"/>
@@ -1974,17 +2130,20 @@
             </a:lvl9pPr>
           </a:lstStyle>
           <a:p>
-            <a:pPr lvl="0"/>
-            <a:r>
-              <a:rPr lang="zh-CN" smtClean="0"/>
-              <a:t>Click to edit Master text styles</a:t>
-            </a:r>
-          </a:p>
-        </p:txBody>
-      </p:sp>
-      <p:sp>
-        <p:nvSpPr>
-          <p:cNvPr id="6" name="Content Placeholder 5"/>
+            <a:pPr lvl="0">
+              <a:defRPr/>
+            </a:pPr>
+            <a:r>
+              <a:rPr lang="zh-CN"/>
+              <a:t>单击此处编辑母版文本样式</a:t>
+            </a:r>
+            <a:endParaRPr/>
+          </a:p>
+        </p:txBody>
+      </p:sp>
+      <p:sp>
+        <p:nvSpPr>
+          <p:cNvPr id="149585165" name="内容占位符 5"/>
           <p:cNvSpPr>
             <a:spLocks noGrp="1"/>
           </p:cNvSpPr>
@@ -1992,9 +2151,9 @@
             <p:ph sz="quarter" idx="4"/>
           </p:nvPr>
         </p:nvSpPr>
-        <p:spPr>
+        <p:spPr bwMode="auto">
           <a:xfrm>
-            <a:off x="6172200" y="2505075"/>
+            <a:off x="6172200" y="2505074"/>
             <a:ext cx="5183188" cy="3684588"/>
           </a:xfrm>
         </p:spPr>
@@ -2002,46 +2161,59 @@
           <a:bodyPr/>
           <a:lstStyle/>
           <a:p>
-            <a:pPr lvl="0"/>
-            <a:r>
-              <a:rPr lang="zh-CN" smtClean="0"/>
-              <a:t>Click to edit Master text styles</a:t>
-            </a:r>
-          </a:p>
-          <a:p>
-            <a:pPr lvl="1"/>
-            <a:r>
-              <a:rPr lang="zh-CN" smtClean="0"/>
-              <a:t>Second level</a:t>
-            </a:r>
-          </a:p>
-          <a:p>
-            <a:pPr lvl="2"/>
-            <a:r>
-              <a:rPr lang="zh-CN" smtClean="0"/>
-              <a:t>Third level</a:t>
-            </a:r>
-          </a:p>
-          <a:p>
-            <a:pPr lvl="3"/>
-            <a:r>
-              <a:rPr lang="zh-CN" smtClean="0"/>
-              <a:t>Fourth level</a:t>
-            </a:r>
-          </a:p>
-          <a:p>
-            <a:pPr lvl="4"/>
-            <a:r>
-              <a:rPr lang="zh-CN" smtClean="0"/>
-              <a:t>Fifth level</a:t>
-            </a:r>
-            <a:endParaRPr lang="zh-CN" dirty="0"/>
-          </a:p>
-        </p:txBody>
-      </p:sp>
-      <p:sp>
-        <p:nvSpPr>
-          <p:cNvPr id="7" name="Date Placeholder 6"/>
+            <a:pPr lvl="0">
+              <a:defRPr/>
+            </a:pPr>
+            <a:r>
+              <a:rPr lang="zh-CN"/>
+              <a:t>单击此处编辑母版文本样式</a:t>
+            </a:r>
+            <a:endParaRPr/>
+          </a:p>
+          <a:p>
+            <a:pPr lvl="1">
+              <a:defRPr/>
+            </a:pPr>
+            <a:r>
+              <a:rPr lang="zh-CN"/>
+              <a:t>二级</a:t>
+            </a:r>
+            <a:endParaRPr/>
+          </a:p>
+          <a:p>
+            <a:pPr lvl="2">
+              <a:defRPr/>
+            </a:pPr>
+            <a:r>
+              <a:rPr lang="zh-CN"/>
+              <a:t>三级</a:t>
+            </a:r>
+            <a:endParaRPr/>
+          </a:p>
+          <a:p>
+            <a:pPr lvl="3">
+              <a:defRPr/>
+            </a:pPr>
+            <a:r>
+              <a:rPr lang="zh-CN"/>
+              <a:t>四级</a:t>
+            </a:r>
+            <a:endParaRPr/>
+          </a:p>
+          <a:p>
+            <a:pPr lvl="4">
+              <a:defRPr/>
+            </a:pPr>
+            <a:r>
+              <a:rPr lang="zh-CN"/>
+              <a:t>五级</a:t>
+            </a:r>
+          </a:p>
+        </p:txBody>
+      </p:sp>
+      <p:sp>
+        <p:nvSpPr>
+          <p:cNvPr id="1746108761" name="日期占位符 6"/>
           <p:cNvSpPr>
             <a:spLocks noGrp="1"/>
           </p:cNvSpPr>
@@ -2049,14 +2221,17 @@
             <p:ph type="dt" sz="half" idx="10"/>
           </p:nvPr>
         </p:nvSpPr>
-        <p:spPr/>
-        <p:txBody>
-          <a:bodyPr/>
-          <a:lstStyle/>
-          <a:p>
+        <p:spPr bwMode="auto"/>
+        <p:txBody>
+          <a:bodyPr/>
+          <a:lstStyle/>
+          <a:p>
+            <a:pPr>
+              <a:defRPr/>
+            </a:pPr>
             <a:fld id="{BCC18F51-09EC-435C-A3BA-64A766E099C0}" type="datetimeFigureOut">
-              <a:rPr lang="zh-CN" smtClean="0"/>
-              <a:t>30.10.2013</a:t>
+              <a:rPr lang="en-US" altLang="zh-CN"/>
+              <a:t>2026/4/10</a:t>
             </a:fld>
             <a:endParaRPr lang="zh-CN"/>
           </a:p>
@@ -2064,7 +2239,7 @@
       </p:sp>
       <p:sp>
         <p:nvSpPr>
-          <p:cNvPr id="8" name="Footer Placeholder 7"/>
+          <p:cNvPr id="2047543986" name="页脚占位符 7"/>
           <p:cNvSpPr>
             <a:spLocks noGrp="1"/>
           </p:cNvSpPr>
@@ -2072,18 +2247,21 @@
             <p:ph type="ftr" sz="quarter" idx="11"/>
           </p:nvPr>
         </p:nvSpPr>
-        <p:spPr/>
-        <p:txBody>
-          <a:bodyPr/>
-          <a:lstStyle/>
-          <a:p>
+        <p:spPr bwMode="auto"/>
+        <p:txBody>
+          <a:bodyPr/>
+          <a:lstStyle/>
+          <a:p>
+            <a:pPr>
+              <a:defRPr/>
+            </a:pPr>
             <a:endParaRPr lang="zh-CN"/>
           </a:p>
         </p:txBody>
       </p:sp>
       <p:sp>
         <p:nvSpPr>
-          <p:cNvPr id="9" name="Slide Number Placeholder 8"/>
+          <p:cNvPr id="2098727764" name="灯片编号占位符 8"/>
           <p:cNvSpPr>
             <a:spLocks noGrp="1"/>
           </p:cNvSpPr>
@@ -2091,13 +2269,16 @@
             <p:ph type="sldNum" sz="quarter" idx="12"/>
           </p:nvPr>
         </p:nvSpPr>
-        <p:spPr/>
-        <p:txBody>
-          <a:bodyPr/>
-          <a:lstStyle/>
-          <a:p>
+        <p:spPr bwMode="auto"/>
+        <p:txBody>
+          <a:bodyPr/>
+          <a:lstStyle/>
+          <a:p>
+            <a:pPr>
+              <a:defRPr/>
+            </a:pPr>
             <a:fld id="{08395586-F03A-48D1-94DF-16B239DF4FB5}" type="slidenum">
-              <a:rPr lang="zh-CN" smtClean="0"/>
+              <a:rPr lang="zh-CN"/>
               <a:t>‹#›</a:t>
             </a:fld>
             <a:endParaRPr lang="zh-CN"/>
@@ -2105,11 +2286,6 @@
         </p:txBody>
       </p:sp>
     </p:spTree>
-    <p:extLst>
-      <p:ext uri="{BB962C8B-B14F-4D97-AF65-F5344CB8AC3E}">
-        <p14:creationId xmlns:p14="http://schemas.microsoft.com/office/powerpoint/2010/main" val="3953759558"/>
-      </p:ext>
-    </p:extLst>
   </p:cSld>
   <p:clrMapOvr>
     <a:masterClrMapping/>
@@ -2118,15 +2294,15 @@
 </file>
 
 <file path=ppt/slideLayouts/slideLayout6.xml><?xml version="1.0" encoding="utf-8"?>
-<p:sldLayout xmlns:a="http://schemas.openxmlformats.org/drawingml/2006/main" xmlns:r="http://schemas.openxmlformats.org/officeDocument/2006/relationships" xmlns:p="http://schemas.openxmlformats.org/presentationml/2006/main" type="titleOnly" preserve="1">
-  <p:cSld name="Title Only">
+<p:sldLayout xmlns:a="http://schemas.openxmlformats.org/drawingml/2006/main" xmlns:r="http://schemas.openxmlformats.org/officeDocument/2006/relationships" xmlns:p="http://schemas.openxmlformats.org/presentationml/2006/main" showMasterPhAnim="0" type="titleOnly" preserve="1" userDrawn="1">
+  <p:cSld name="仅标题">
     <p:spTree>
       <p:nvGrpSpPr>
         <p:cNvPr id="1" name=""/>
         <p:cNvGrpSpPr/>
         <p:nvPr/>
       </p:nvGrpSpPr>
-      <p:grpSpPr>
+      <p:grpSpPr bwMode="auto">
         <a:xfrm>
           <a:off x="0" y="0"/>
           <a:ext cx="0" cy="0"/>
@@ -2136,7 +2312,7 @@
       </p:grpSpPr>
       <p:sp>
         <p:nvSpPr>
-          <p:cNvPr id="2" name="Title 1"/>
+          <p:cNvPr id="897274108" name="标题 1"/>
           <p:cNvSpPr>
             <a:spLocks noGrp="1"/>
           </p:cNvSpPr>
@@ -2144,22 +2320,24 @@
             <p:ph type="title"/>
           </p:nvPr>
         </p:nvSpPr>
-        <p:spPr/>
-        <p:txBody>
-          <a:bodyPr/>
-          <a:lstStyle/>
-          <a:p>
-            <a:r>
-              <a:rPr lang="zh-CN" smtClean="0"/>
-              <a:t>Click to edit Master title style</a:t>
-            </a:r>
-            <a:endParaRPr lang="zh-CN" dirty="0"/>
-          </a:p>
-        </p:txBody>
-      </p:sp>
-      <p:sp>
-        <p:nvSpPr>
-          <p:cNvPr id="3" name="Date Placeholder 2"/>
+        <p:spPr bwMode="auto"/>
+        <p:txBody>
+          <a:bodyPr/>
+          <a:lstStyle/>
+          <a:p>
+            <a:pPr>
+              <a:defRPr/>
+            </a:pPr>
+            <a:r>
+              <a:rPr lang="zh-CN"/>
+              <a:t>单击此处编辑母版标题样式</a:t>
+            </a:r>
+          </a:p>
+        </p:txBody>
+      </p:sp>
+      <p:sp>
+        <p:nvSpPr>
+          <p:cNvPr id="1536027858" name="日期占位符 2"/>
           <p:cNvSpPr>
             <a:spLocks noGrp="1"/>
           </p:cNvSpPr>
@@ -2167,14 +2345,17 @@
             <p:ph type="dt" sz="half" idx="10"/>
           </p:nvPr>
         </p:nvSpPr>
-        <p:spPr/>
-        <p:txBody>
-          <a:bodyPr/>
-          <a:lstStyle/>
-          <a:p>
+        <p:spPr bwMode="auto"/>
+        <p:txBody>
+          <a:bodyPr/>
+          <a:lstStyle/>
+          <a:p>
+            <a:pPr>
+              <a:defRPr/>
+            </a:pPr>
             <a:fld id="{BCC18F51-09EC-435C-A3BA-64A766E099C0}" type="datetimeFigureOut">
-              <a:rPr lang="zh-CN" smtClean="0"/>
-              <a:t>30.10.2013</a:t>
+              <a:rPr lang="en-US" altLang="zh-CN"/>
+              <a:t>2026/4/10</a:t>
             </a:fld>
             <a:endParaRPr lang="zh-CN"/>
           </a:p>
@@ -2182,7 +2363,7 @@
       </p:sp>
       <p:sp>
         <p:nvSpPr>
-          <p:cNvPr id="4" name="Footer Placeholder 3"/>
+          <p:cNvPr id="718693365" name="页脚占位符 3"/>
           <p:cNvSpPr>
             <a:spLocks noGrp="1"/>
           </p:cNvSpPr>
@@ -2190,18 +2371,21 @@
             <p:ph type="ftr" sz="quarter" idx="11"/>
           </p:nvPr>
         </p:nvSpPr>
-        <p:spPr/>
-        <p:txBody>
-          <a:bodyPr/>
-          <a:lstStyle/>
-          <a:p>
+        <p:spPr bwMode="auto"/>
+        <p:txBody>
+          <a:bodyPr/>
+          <a:lstStyle/>
+          <a:p>
+            <a:pPr>
+              <a:defRPr/>
+            </a:pPr>
             <a:endParaRPr lang="zh-CN"/>
           </a:p>
         </p:txBody>
       </p:sp>
       <p:sp>
         <p:nvSpPr>
-          <p:cNvPr id="5" name="Slide Number Placeholder 4"/>
+          <p:cNvPr id="787523423" name="灯片编号占位符 4"/>
           <p:cNvSpPr>
             <a:spLocks noGrp="1"/>
           </p:cNvSpPr>
@@ -2209,13 +2393,16 @@
             <p:ph type="sldNum" sz="quarter" idx="12"/>
           </p:nvPr>
         </p:nvSpPr>
-        <p:spPr/>
-        <p:txBody>
-          <a:bodyPr/>
-          <a:lstStyle/>
-          <a:p>
+        <p:spPr bwMode="auto"/>
+        <p:txBody>
+          <a:bodyPr/>
+          <a:lstStyle/>
+          <a:p>
+            <a:pPr>
+              <a:defRPr/>
+            </a:pPr>
             <a:fld id="{08395586-F03A-48D1-94DF-16B239DF4FB5}" type="slidenum">
-              <a:rPr lang="zh-CN" smtClean="0"/>
+              <a:rPr lang="zh-CN"/>
               <a:t>‹#›</a:t>
             </a:fld>
             <a:endParaRPr lang="zh-CN"/>
@@ -2223,11 +2410,6 @@
         </p:txBody>
       </p:sp>
     </p:spTree>
-    <p:extLst>
-      <p:ext uri="{BB962C8B-B14F-4D97-AF65-F5344CB8AC3E}">
-        <p14:creationId xmlns:p14="http://schemas.microsoft.com/office/powerpoint/2010/main" val="3815284972"/>
-      </p:ext>
-    </p:extLst>
   </p:cSld>
   <p:clrMapOvr>
     <a:masterClrMapping/>
@@ -2236,15 +2418,15 @@
 </file>
 
 <file path=ppt/slideLayouts/slideLayout7.xml><?xml version="1.0" encoding="utf-8"?>
-<p:sldLayout xmlns:a="http://schemas.openxmlformats.org/drawingml/2006/main" xmlns:r="http://schemas.openxmlformats.org/officeDocument/2006/relationships" xmlns:p="http://schemas.openxmlformats.org/presentationml/2006/main" type="blank" preserve="1">
-  <p:cSld name="Blank">
+<p:sldLayout xmlns:a="http://schemas.openxmlformats.org/drawingml/2006/main" xmlns:r="http://schemas.openxmlformats.org/officeDocument/2006/relationships" xmlns:p="http://schemas.openxmlformats.org/presentationml/2006/main" showMasterPhAnim="0" type="blank" preserve="1" userDrawn="1">
+  <p:cSld name="空白">
     <p:spTree>
       <p:nvGrpSpPr>
         <p:cNvPr id="1" name=""/>
         <p:cNvGrpSpPr/>
         <p:nvPr/>
       </p:nvGrpSpPr>
-      <p:grpSpPr>
+      <p:grpSpPr bwMode="auto">
         <a:xfrm>
           <a:off x="0" y="0"/>
           <a:ext cx="0" cy="0"/>
@@ -2254,7 +2436,7 @@
       </p:grpSpPr>
       <p:sp>
         <p:nvSpPr>
-          <p:cNvPr id="2" name="Date Placeholder 1"/>
+          <p:cNvPr id="993666087" name="日期占位符 1"/>
           <p:cNvSpPr>
             <a:spLocks noGrp="1"/>
           </p:cNvSpPr>
@@ -2262,14 +2444,17 @@
             <p:ph type="dt" sz="half" idx="10"/>
           </p:nvPr>
         </p:nvSpPr>
-        <p:spPr/>
-        <p:txBody>
-          <a:bodyPr/>
-          <a:lstStyle/>
-          <a:p>
+        <p:spPr bwMode="auto"/>
+        <p:txBody>
+          <a:bodyPr/>
+          <a:lstStyle/>
+          <a:p>
+            <a:pPr>
+              <a:defRPr/>
+            </a:pPr>
             <a:fld id="{BCC18F51-09EC-435C-A3BA-64A766E099C0}" type="datetimeFigureOut">
-              <a:rPr lang="zh-CN" smtClean="0"/>
-              <a:t>30.10.2013</a:t>
+              <a:rPr lang="en-US" altLang="zh-CN"/>
+              <a:t>2026/4/10</a:t>
             </a:fld>
             <a:endParaRPr lang="zh-CN"/>
           </a:p>
@@ -2277,7 +2462,7 @@
       </p:sp>
       <p:sp>
         <p:nvSpPr>
-          <p:cNvPr id="3" name="Footer Placeholder 2"/>
+          <p:cNvPr id="579156694" name="页脚占位符 2"/>
           <p:cNvSpPr>
             <a:spLocks noGrp="1"/>
           </p:cNvSpPr>
@@ -2285,18 +2470,21 @@
             <p:ph type="ftr" sz="quarter" idx="11"/>
           </p:nvPr>
         </p:nvSpPr>
-        <p:spPr/>
-        <p:txBody>
-          <a:bodyPr/>
-          <a:lstStyle/>
-          <a:p>
+        <p:spPr bwMode="auto"/>
+        <p:txBody>
+          <a:bodyPr/>
+          <a:lstStyle/>
+          <a:p>
+            <a:pPr>
+              <a:defRPr/>
+            </a:pPr>
             <a:endParaRPr lang="zh-CN"/>
           </a:p>
         </p:txBody>
       </p:sp>
       <p:sp>
         <p:nvSpPr>
-          <p:cNvPr id="4" name="Slide Number Placeholder 3"/>
+          <p:cNvPr id="1559616132" name="灯片编号占位符 3"/>
           <p:cNvSpPr>
             <a:spLocks noGrp="1"/>
           </p:cNvSpPr>
@@ -2304,13 +2492,16 @@
             <p:ph type="sldNum" sz="quarter" idx="12"/>
           </p:nvPr>
         </p:nvSpPr>
-        <p:spPr/>
-        <p:txBody>
-          <a:bodyPr/>
-          <a:lstStyle/>
-          <a:p>
+        <p:spPr bwMode="auto"/>
+        <p:txBody>
+          <a:bodyPr/>
+          <a:lstStyle/>
+          <a:p>
+            <a:pPr>
+              <a:defRPr/>
+            </a:pPr>
             <a:fld id="{08395586-F03A-48D1-94DF-16B239DF4FB5}" type="slidenum">
-              <a:rPr lang="zh-CN" smtClean="0"/>
+              <a:rPr lang="zh-CN"/>
               <a:t>‹#›</a:t>
             </a:fld>
             <a:endParaRPr lang="zh-CN"/>
@@ -2318,11 +2509,6 @@
         </p:txBody>
       </p:sp>
     </p:spTree>
-    <p:extLst>
-      <p:ext uri="{BB962C8B-B14F-4D97-AF65-F5344CB8AC3E}">
-        <p14:creationId xmlns:p14="http://schemas.microsoft.com/office/powerpoint/2010/main" val="3035599116"/>
-      </p:ext>
-    </p:extLst>
   </p:cSld>
   <p:clrMapOvr>
     <a:masterClrMapping/>
@@ -2331,15 +2517,15 @@
 </file>
 
 <file path=ppt/slideLayouts/slideLayout8.xml><?xml version="1.0" encoding="utf-8"?>
-<p:sldLayout xmlns:a="http://schemas.openxmlformats.org/drawingml/2006/main" xmlns:r="http://schemas.openxmlformats.org/officeDocument/2006/relationships" xmlns:p="http://schemas.openxmlformats.org/presentationml/2006/main" type="objTx" preserve="1">
-  <p:cSld name="Content with Caption">
+<p:sldLayout xmlns:a="http://schemas.openxmlformats.org/drawingml/2006/main" xmlns:r="http://schemas.openxmlformats.org/officeDocument/2006/relationships" xmlns:p="http://schemas.openxmlformats.org/presentationml/2006/main" showMasterPhAnim="0" type="objTx" preserve="1" userDrawn="1">
+  <p:cSld name="内容与标题">
     <p:spTree>
       <p:nvGrpSpPr>
         <p:cNvPr id="1" name=""/>
         <p:cNvGrpSpPr/>
         <p:nvPr/>
       </p:nvGrpSpPr>
-      <p:grpSpPr>
+      <p:grpSpPr bwMode="auto">
         <a:xfrm>
           <a:off x="0" y="0"/>
           <a:ext cx="0" cy="0"/>
@@ -2349,7 +2535,7 @@
       </p:grpSpPr>
       <p:sp>
         <p:nvSpPr>
-          <p:cNvPr id="2" name="Title 1"/>
+          <p:cNvPr id="449256111" name="标题 1"/>
           <p:cNvSpPr>
             <a:spLocks noGrp="1"/>
           </p:cNvSpPr>
@@ -2357,7 +2543,7 @@
             <p:ph type="title"/>
           </p:nvPr>
         </p:nvSpPr>
-        <p:spPr>
+        <p:spPr bwMode="auto">
           <a:xfrm>
             <a:off x="839788" y="457200"/>
             <a:ext cx="3932237" cy="1600200"/>
@@ -2371,17 +2557,19 @@
             </a:lvl1pPr>
           </a:lstStyle>
           <a:p>
-            <a:r>
-              <a:rPr lang="zh-CN" smtClean="0"/>
-              <a:t>Click to edit Master title style</a:t>
-            </a:r>
-            <a:endParaRPr lang="zh-CN" dirty="0"/>
-          </a:p>
-        </p:txBody>
-      </p:sp>
-      <p:sp>
-        <p:nvSpPr>
-          <p:cNvPr id="3" name="Content Placeholder 2"/>
+            <a:pPr>
+              <a:defRPr/>
+            </a:pPr>
+            <a:r>
+              <a:rPr lang="zh-CN"/>
+              <a:t>单击此处编辑母版标题样式</a:t>
+            </a:r>
+          </a:p>
+        </p:txBody>
+      </p:sp>
+      <p:sp>
+        <p:nvSpPr>
+          <p:cNvPr id="1892078191" name="内容占位符 2"/>
           <p:cNvSpPr>
             <a:spLocks noGrp="1"/>
           </p:cNvSpPr>
@@ -2389,7 +2577,7 @@
             <p:ph idx="1"/>
           </p:nvPr>
         </p:nvSpPr>
-        <p:spPr>
+        <p:spPr bwMode="auto">
           <a:xfrm>
             <a:off x="5183188" y="987425"/>
             <a:ext cx="6172200" cy="4873625"/>
@@ -2427,46 +2615,59 @@
             </a:lvl9pPr>
           </a:lstStyle>
           <a:p>
-            <a:pPr lvl="0"/>
-            <a:r>
-              <a:rPr lang="zh-CN" smtClean="0"/>
-              <a:t>Click to edit Master text styles</a:t>
-            </a:r>
-          </a:p>
-          <a:p>
-            <a:pPr lvl="1"/>
-            <a:r>
-              <a:rPr lang="zh-CN" smtClean="0"/>
-              <a:t>Second level</a:t>
-            </a:r>
-          </a:p>
-          <a:p>
-            <a:pPr lvl="2"/>
-            <a:r>
-              <a:rPr lang="zh-CN" smtClean="0"/>
-              <a:t>Third level</a:t>
-            </a:r>
-          </a:p>
-          <a:p>
-            <a:pPr lvl="3"/>
-            <a:r>
-              <a:rPr lang="zh-CN" smtClean="0"/>
-              <a:t>Fourth level</a:t>
-            </a:r>
-          </a:p>
-          <a:p>
-            <a:pPr lvl="4"/>
-            <a:r>
-              <a:rPr lang="zh-CN" smtClean="0"/>
-              <a:t>Fifth level</a:t>
-            </a:r>
-            <a:endParaRPr lang="zh-CN" dirty="0"/>
-          </a:p>
-        </p:txBody>
-      </p:sp>
-      <p:sp>
-        <p:nvSpPr>
-          <p:cNvPr id="4" name="Text Placeholder 3"/>
+            <a:pPr lvl="0">
+              <a:defRPr/>
+            </a:pPr>
+            <a:r>
+              <a:rPr lang="zh-CN"/>
+              <a:t>单击此处编辑母版文本样式</a:t>
+            </a:r>
+            <a:endParaRPr/>
+          </a:p>
+          <a:p>
+            <a:pPr lvl="1">
+              <a:defRPr/>
+            </a:pPr>
+            <a:r>
+              <a:rPr lang="zh-CN"/>
+              <a:t>二级</a:t>
+            </a:r>
+            <a:endParaRPr/>
+          </a:p>
+          <a:p>
+            <a:pPr lvl="2">
+              <a:defRPr/>
+            </a:pPr>
+            <a:r>
+              <a:rPr lang="zh-CN"/>
+              <a:t>三级</a:t>
+            </a:r>
+            <a:endParaRPr/>
+          </a:p>
+          <a:p>
+            <a:pPr lvl="3">
+              <a:defRPr/>
+            </a:pPr>
+            <a:r>
+              <a:rPr lang="zh-CN"/>
+              <a:t>四级</a:t>
+            </a:r>
+            <a:endParaRPr/>
+          </a:p>
+          <a:p>
+            <a:pPr lvl="4">
+              <a:defRPr/>
+            </a:pPr>
+            <a:r>
+              <a:rPr lang="zh-CN"/>
+              <a:t>五级</a:t>
+            </a:r>
+          </a:p>
+        </p:txBody>
+      </p:sp>
+      <p:sp>
+        <p:nvSpPr>
+          <p:cNvPr id="473690543" name="文本占位符 3"/>
           <p:cNvSpPr>
             <a:spLocks noGrp="1"/>
           </p:cNvSpPr>
@@ -2474,7 +2675,7 @@
             <p:ph type="body" sz="half" idx="2"/>
           </p:nvPr>
         </p:nvSpPr>
-        <p:spPr>
+        <p:spPr bwMode="auto">
           <a:xfrm>
             <a:off x="839788" y="2057400"/>
             <a:ext cx="3932237" cy="3811588"/>
@@ -2521,17 +2722,20 @@
             </a:lvl9pPr>
           </a:lstStyle>
           <a:p>
-            <a:pPr lvl="0"/>
-            <a:r>
-              <a:rPr lang="zh-CN" smtClean="0"/>
-              <a:t>Click to edit Master text styles</a:t>
-            </a:r>
-          </a:p>
-        </p:txBody>
-      </p:sp>
-      <p:sp>
-        <p:nvSpPr>
-          <p:cNvPr id="5" name="Date Placeholder 4"/>
+            <a:pPr lvl="0">
+              <a:defRPr/>
+            </a:pPr>
+            <a:r>
+              <a:rPr lang="zh-CN"/>
+              <a:t>单击此处编辑母版文本样式</a:t>
+            </a:r>
+            <a:endParaRPr/>
+          </a:p>
+        </p:txBody>
+      </p:sp>
+      <p:sp>
+        <p:nvSpPr>
+          <p:cNvPr id="398524071" name="日期占位符 4"/>
           <p:cNvSpPr>
             <a:spLocks noGrp="1"/>
           </p:cNvSpPr>
@@ -2539,14 +2743,17 @@
             <p:ph type="dt" sz="half" idx="10"/>
           </p:nvPr>
         </p:nvSpPr>
-        <p:spPr/>
-        <p:txBody>
-          <a:bodyPr/>
-          <a:lstStyle/>
-          <a:p>
+        <p:spPr bwMode="auto"/>
+        <p:txBody>
+          <a:bodyPr/>
+          <a:lstStyle/>
+          <a:p>
+            <a:pPr>
+              <a:defRPr/>
+            </a:pPr>
             <a:fld id="{BCC18F51-09EC-435C-A3BA-64A766E099C0}" type="datetimeFigureOut">
-              <a:rPr lang="zh-CN" smtClean="0"/>
-              <a:t>30.10.2013</a:t>
+              <a:rPr lang="en-US" altLang="zh-CN"/>
+              <a:t>2026/4/10</a:t>
             </a:fld>
             <a:endParaRPr lang="zh-CN"/>
           </a:p>
@@ -2554,7 +2761,7 @@
       </p:sp>
       <p:sp>
         <p:nvSpPr>
-          <p:cNvPr id="6" name="Footer Placeholder 5"/>
+          <p:cNvPr id="702525442" name="页脚占位符 5"/>
           <p:cNvSpPr>
             <a:spLocks noGrp="1"/>
           </p:cNvSpPr>
@@ -2562,18 +2769,21 @@
             <p:ph type="ftr" sz="quarter" idx="11"/>
           </p:nvPr>
         </p:nvSpPr>
-        <p:spPr/>
-        <p:txBody>
-          <a:bodyPr/>
-          <a:lstStyle/>
-          <a:p>
+        <p:spPr bwMode="auto"/>
+        <p:txBody>
+          <a:bodyPr/>
+          <a:lstStyle/>
+          <a:p>
+            <a:pPr>
+              <a:defRPr/>
+            </a:pPr>
             <a:endParaRPr lang="zh-CN"/>
           </a:p>
         </p:txBody>
       </p:sp>
       <p:sp>
         <p:nvSpPr>
-          <p:cNvPr id="7" name="Slide Number Placeholder 6"/>
+          <p:cNvPr id="1412872458" name="灯片编号占位符 6"/>
           <p:cNvSpPr>
             <a:spLocks noGrp="1"/>
           </p:cNvSpPr>
@@ -2581,13 +2791,16 @@
             <p:ph type="sldNum" sz="quarter" idx="12"/>
           </p:nvPr>
         </p:nvSpPr>
-        <p:spPr/>
-        <p:txBody>
-          <a:bodyPr/>
-          <a:lstStyle/>
-          <a:p>
+        <p:spPr bwMode="auto"/>
+        <p:txBody>
+          <a:bodyPr/>
+          <a:lstStyle/>
+          <a:p>
+            <a:pPr>
+              <a:defRPr/>
+            </a:pPr>
             <a:fld id="{08395586-F03A-48D1-94DF-16B239DF4FB5}" type="slidenum">
-              <a:rPr lang="zh-CN" smtClean="0"/>
+              <a:rPr lang="zh-CN"/>
               <a:t>‹#›</a:t>
             </a:fld>
             <a:endParaRPr lang="zh-CN"/>
@@ -2595,11 +2808,6 @@
         </p:txBody>
       </p:sp>
     </p:spTree>
-    <p:extLst>
-      <p:ext uri="{BB962C8B-B14F-4D97-AF65-F5344CB8AC3E}">
-        <p14:creationId xmlns:p14="http://schemas.microsoft.com/office/powerpoint/2010/main" val="1714960738"/>
-      </p:ext>
-    </p:extLst>
   </p:cSld>
   <p:clrMapOvr>
     <a:masterClrMapping/>
@@ -2608,15 +2816,15 @@
 </file>
 
 <file path=ppt/slideLayouts/slideLayout9.xml><?xml version="1.0" encoding="utf-8"?>
-<p:sldLayout xmlns:a="http://schemas.openxmlformats.org/drawingml/2006/main" xmlns:r="http://schemas.openxmlformats.org/officeDocument/2006/relationships" xmlns:p="http://schemas.openxmlformats.org/presentationml/2006/main" type="picTx" preserve="1">
-  <p:cSld name="Picture with Caption">
+<p:sldLayout xmlns:a="http://schemas.openxmlformats.org/drawingml/2006/main" xmlns:r="http://schemas.openxmlformats.org/officeDocument/2006/relationships" xmlns:p="http://schemas.openxmlformats.org/presentationml/2006/main" showMasterPhAnim="0" type="picTx" preserve="1" userDrawn="1">
+  <p:cSld name="图片与标题">
     <p:spTree>
       <p:nvGrpSpPr>
         <p:cNvPr id="1" name=""/>
         <p:cNvGrpSpPr/>
         <p:nvPr/>
       </p:nvGrpSpPr>
-      <p:grpSpPr>
+      <p:grpSpPr bwMode="auto">
         <a:xfrm>
           <a:off x="0" y="0"/>
           <a:ext cx="0" cy="0"/>
@@ -2626,7 +2834,7 @@
       </p:grpSpPr>
       <p:sp>
         <p:nvSpPr>
-          <p:cNvPr id="2" name="Title 1"/>
+          <p:cNvPr id="62192004" name="标题 1"/>
           <p:cNvSpPr>
             <a:spLocks noGrp="1"/>
           </p:cNvSpPr>
@@ -2634,7 +2842,7 @@
             <p:ph type="title"/>
           </p:nvPr>
         </p:nvSpPr>
-        <p:spPr>
+        <p:spPr bwMode="auto">
           <a:xfrm>
             <a:off x="839788" y="457200"/>
             <a:ext cx="3932237" cy="1600200"/>
@@ -2648,17 +2856,19 @@
             </a:lvl1pPr>
           </a:lstStyle>
           <a:p>
-            <a:r>
-              <a:rPr lang="zh-CN" smtClean="0"/>
-              <a:t>Click to edit Master title style</a:t>
-            </a:r>
-            <a:endParaRPr lang="zh-CN" dirty="0"/>
-          </a:p>
-        </p:txBody>
-      </p:sp>
-      <p:sp>
-        <p:nvSpPr>
-          <p:cNvPr id="3" name="Picture Placeholder 2"/>
+            <a:pPr>
+              <a:defRPr/>
+            </a:pPr>
+            <a:r>
+              <a:rPr lang="zh-CN"/>
+              <a:t>单击此处编辑母版标题样式</a:t>
+            </a:r>
+          </a:p>
+        </p:txBody>
+      </p:sp>
+      <p:sp>
+        <p:nvSpPr>
+          <p:cNvPr id="1223859761" name="图片占位符 2"/>
           <p:cNvSpPr>
             <a:spLocks noGrp="1" noChangeAspect="1"/>
           </p:cNvSpPr>
@@ -2666,7 +2876,7 @@
             <p:ph type="pic" idx="1"/>
           </p:nvPr>
         </p:nvSpPr>
-        <p:spPr>
+        <p:spPr bwMode="auto">
           <a:xfrm>
             <a:off x="5183188" y="987425"/>
             <a:ext cx="6172200" cy="4873625"/>
@@ -2713,17 +2923,19 @@
             </a:lvl9pPr>
           </a:lstStyle>
           <a:p>
-            <a:r>
-              <a:rPr lang="zh-CN" smtClean="0"/>
-              <a:t>Click icon to add picture</a:t>
-            </a:r>
-            <a:endParaRPr lang="zh-CN" dirty="0"/>
-          </a:p>
-        </p:txBody>
-      </p:sp>
-      <p:sp>
-        <p:nvSpPr>
-          <p:cNvPr id="4" name="Text Placeholder 3"/>
+            <a:pPr>
+              <a:defRPr/>
+            </a:pPr>
+            <a:r>
+              <a:rPr lang="zh-CN"/>
+              <a:t>點擊圖示以新增圖片</a:t>
+            </a:r>
+          </a:p>
+        </p:txBody>
+      </p:sp>
+      <p:sp>
+        <p:nvSpPr>
+          <p:cNvPr id="1219796352" name="文本占位符 3"/>
           <p:cNvSpPr>
             <a:spLocks noGrp="1"/>
           </p:cNvSpPr>
@@ -2731,7 +2943,7 @@
             <p:ph type="body" sz="half" idx="2"/>
           </p:nvPr>
         </p:nvSpPr>
-        <p:spPr>
+        <p:spPr bwMode="auto">
           <a:xfrm>
             <a:off x="839788" y="2057400"/>
             <a:ext cx="3932237" cy="3811588"/>
@@ -2778,17 +2990,20 @@
             </a:lvl9pPr>
           </a:lstStyle>
           <a:p>
-            <a:pPr lvl="0"/>
-            <a:r>
-              <a:rPr lang="zh-CN" smtClean="0"/>
-              <a:t>Click to edit Master text styles</a:t>
-            </a:r>
-          </a:p>
-        </p:txBody>
-      </p:sp>
-      <p:sp>
-        <p:nvSpPr>
-          <p:cNvPr id="5" name="Date Placeholder 4"/>
+            <a:pPr lvl="0">
+              <a:defRPr/>
+            </a:pPr>
+            <a:r>
+              <a:rPr lang="zh-CN"/>
+              <a:t>单击此处编辑母版文本样式</a:t>
+            </a:r>
+            <a:endParaRPr/>
+          </a:p>
+        </p:txBody>
+      </p:sp>
+      <p:sp>
+        <p:nvSpPr>
+          <p:cNvPr id="1320725460" name="日期占位符 4"/>
           <p:cNvSpPr>
             <a:spLocks noGrp="1"/>
           </p:cNvSpPr>
@@ -2796,14 +3011,17 @@
             <p:ph type="dt" sz="half" idx="10"/>
           </p:nvPr>
         </p:nvSpPr>
-        <p:spPr/>
-        <p:txBody>
-          <a:bodyPr/>
-          <a:lstStyle/>
-          <a:p>
+        <p:spPr bwMode="auto"/>
+        <p:txBody>
+          <a:bodyPr/>
+          <a:lstStyle/>
+          <a:p>
+            <a:pPr>
+              <a:defRPr/>
+            </a:pPr>
             <a:fld id="{BCC18F51-09EC-435C-A3BA-64A766E099C0}" type="datetimeFigureOut">
-              <a:rPr lang="zh-CN" smtClean="0"/>
-              <a:t>30.10.2013</a:t>
+              <a:rPr lang="en-US" altLang="zh-CN"/>
+              <a:t>2026/4/10</a:t>
             </a:fld>
             <a:endParaRPr lang="zh-CN"/>
           </a:p>
@@ -2811,7 +3029,7 @@
       </p:sp>
       <p:sp>
         <p:nvSpPr>
-          <p:cNvPr id="6" name="Footer Placeholder 5"/>
+          <p:cNvPr id="1211124596" name="页脚占位符 5"/>
           <p:cNvSpPr>
             <a:spLocks noGrp="1"/>
           </p:cNvSpPr>
@@ -2819,18 +3037,21 @@
             <p:ph type="ftr" sz="quarter" idx="11"/>
           </p:nvPr>
         </p:nvSpPr>
-        <p:spPr/>
-        <p:txBody>
-          <a:bodyPr/>
-          <a:lstStyle/>
-          <a:p>
+        <p:spPr bwMode="auto"/>
+        <p:txBody>
+          <a:bodyPr/>
+          <a:lstStyle/>
+          <a:p>
+            <a:pPr>
+              <a:defRPr/>
+            </a:pPr>
             <a:endParaRPr lang="zh-CN"/>
           </a:p>
         </p:txBody>
       </p:sp>
       <p:sp>
         <p:nvSpPr>
-          <p:cNvPr id="7" name="Slide Number Placeholder 6"/>
+          <p:cNvPr id="1890298523" name="灯片编号占位符 6"/>
           <p:cNvSpPr>
             <a:spLocks noGrp="1"/>
           </p:cNvSpPr>
@@ -2838,13 +3059,16 @@
             <p:ph type="sldNum" sz="quarter" idx="12"/>
           </p:nvPr>
         </p:nvSpPr>
-        <p:spPr/>
-        <p:txBody>
-          <a:bodyPr/>
-          <a:lstStyle/>
-          <a:p>
+        <p:spPr bwMode="auto"/>
+        <p:txBody>
+          <a:bodyPr/>
+          <a:lstStyle/>
+          <a:p>
+            <a:pPr>
+              <a:defRPr/>
+            </a:pPr>
             <a:fld id="{08395586-F03A-48D1-94DF-16B239DF4FB5}" type="slidenum">
-              <a:rPr lang="zh-CN" smtClean="0"/>
+              <a:rPr lang="zh-CN"/>
               <a:t>‹#›</a:t>
             </a:fld>
             <a:endParaRPr lang="zh-CN"/>
@@ -2852,11 +3076,6 @@
         </p:txBody>
       </p:sp>
     </p:spTree>
-    <p:extLst>
-      <p:ext uri="{BB962C8B-B14F-4D97-AF65-F5344CB8AC3E}">
-        <p14:creationId xmlns:p14="http://schemas.microsoft.com/office/powerpoint/2010/main" val="3255540774"/>
-      </p:ext>
-    </p:extLst>
   </p:cSld>
   <p:clrMapOvr>
     <a:masterClrMapping/>
@@ -2878,7 +3097,7 @@
         <p:cNvGrpSpPr/>
         <p:nvPr/>
       </p:nvGrpSpPr>
-      <p:grpSpPr>
+      <p:grpSpPr bwMode="auto">
         <a:xfrm>
           <a:off x="0" y="0"/>
           <a:ext cx="0" cy="0"/>
@@ -2888,7 +3107,7 @@
       </p:grpSpPr>
       <p:sp>
         <p:nvSpPr>
-          <p:cNvPr id="2" name="Title Placeholder 1"/>
+          <p:cNvPr id="383200383" name="标题占位符 1"/>
           <p:cNvSpPr>
             <a:spLocks noGrp="1"/>
           </p:cNvSpPr>
@@ -2896,7 +3115,7 @@
             <p:ph type="title"/>
           </p:nvPr>
         </p:nvSpPr>
-        <p:spPr>
+        <p:spPr bwMode="auto">
           <a:xfrm>
             <a:off x="838200" y="365125"/>
             <a:ext cx="10515600" cy="1325563"/>
@@ -2911,17 +3130,19 @@
           </a:bodyPr>
           <a:lstStyle/>
           <a:p>
-            <a:r>
-              <a:rPr lang="zh-CN" smtClean="0"/>
-              <a:t>Click to edit Master title style</a:t>
-            </a:r>
-            <a:endParaRPr lang="zh-CN" dirty="0"/>
-          </a:p>
-        </p:txBody>
-      </p:sp>
-      <p:sp>
-        <p:nvSpPr>
-          <p:cNvPr id="3" name="Text Placeholder 2"/>
+            <a:pPr>
+              <a:defRPr/>
+            </a:pPr>
+            <a:r>
+              <a:rPr lang="zh-CN"/>
+              <a:t>单击此处编辑母版标题样式</a:t>
+            </a:r>
+          </a:p>
+        </p:txBody>
+      </p:sp>
+      <p:sp>
+        <p:nvSpPr>
+          <p:cNvPr id="102205264" name="文本占位符 2"/>
           <p:cNvSpPr>
             <a:spLocks noGrp="1"/>
           </p:cNvSpPr>
@@ -2929,7 +3150,7 @@
             <p:ph type="body" idx="1"/>
           </p:nvPr>
         </p:nvSpPr>
-        <p:spPr>
+        <p:spPr bwMode="auto">
           <a:xfrm>
             <a:off x="838200" y="1825625"/>
             <a:ext cx="10515600" cy="4351338"/>
@@ -2944,46 +3165,59 @@
           </a:bodyPr>
           <a:lstStyle/>
           <a:p>
-            <a:pPr lvl="0"/>
-            <a:r>
-              <a:rPr lang="zh-CN" smtClean="0"/>
-              <a:t>Click to edit Master text styles</a:t>
-            </a:r>
-          </a:p>
-          <a:p>
-            <a:pPr lvl="1"/>
-            <a:r>
-              <a:rPr lang="zh-CN" smtClean="0"/>
-              <a:t>Second level</a:t>
-            </a:r>
-          </a:p>
-          <a:p>
-            <a:pPr lvl="2"/>
-            <a:r>
-              <a:rPr lang="zh-CN" smtClean="0"/>
-              <a:t>Third level</a:t>
-            </a:r>
-          </a:p>
-          <a:p>
-            <a:pPr lvl="3"/>
-            <a:r>
-              <a:rPr lang="zh-CN" smtClean="0"/>
-              <a:t>Fourth level</a:t>
-            </a:r>
-          </a:p>
-          <a:p>
-            <a:pPr lvl="4"/>
-            <a:r>
-              <a:rPr lang="zh-CN" smtClean="0"/>
-              <a:t>Fifth level</a:t>
-            </a:r>
-            <a:endParaRPr lang="zh-CN" dirty="0"/>
-          </a:p>
-        </p:txBody>
-      </p:sp>
-      <p:sp>
-        <p:nvSpPr>
-          <p:cNvPr id="4" name="Date Placeholder 3"/>
+            <a:pPr lvl="0">
+              <a:defRPr/>
+            </a:pPr>
+            <a:r>
+              <a:rPr lang="zh-CN"/>
+              <a:t>单击此处编辑母版文本样式</a:t>
+            </a:r>
+            <a:endParaRPr/>
+          </a:p>
+          <a:p>
+            <a:pPr lvl="1">
+              <a:defRPr/>
+            </a:pPr>
+            <a:r>
+              <a:rPr lang="zh-CN"/>
+              <a:t>二级</a:t>
+            </a:r>
+            <a:endParaRPr/>
+          </a:p>
+          <a:p>
+            <a:pPr lvl="2">
+              <a:defRPr/>
+            </a:pPr>
+            <a:r>
+              <a:rPr lang="zh-CN"/>
+              <a:t>三级</a:t>
+            </a:r>
+            <a:endParaRPr/>
+          </a:p>
+          <a:p>
+            <a:pPr lvl="3">
+              <a:defRPr/>
+            </a:pPr>
+            <a:r>
+              <a:rPr lang="zh-CN"/>
+              <a:t>四级</a:t>
+            </a:r>
+            <a:endParaRPr/>
+          </a:p>
+          <a:p>
+            <a:pPr lvl="4">
+              <a:defRPr/>
+            </a:pPr>
+            <a:r>
+              <a:rPr lang="zh-CN"/>
+              <a:t>五级</a:t>
+            </a:r>
+          </a:p>
+        </p:txBody>
+      </p:sp>
+      <p:sp>
+        <p:nvSpPr>
+          <p:cNvPr id="777740504" name="日期占位符 3"/>
           <p:cNvSpPr>
             <a:spLocks noGrp="1"/>
           </p:cNvSpPr>
@@ -2991,7 +3225,7 @@
             <p:ph type="dt" sz="half" idx="2"/>
           </p:nvPr>
         </p:nvSpPr>
-        <p:spPr>
+        <p:spPr bwMode="auto">
           <a:xfrm>
             <a:off x="838200" y="6356350"/>
             <a:ext cx="2743200" cy="365125"/>
@@ -3002,21 +3236,14 @@
         </p:spPr>
         <p:txBody>
           <a:bodyPr vert="horz" lIns="91440" tIns="45720" rIns="91440" bIns="45720" rtlCol="0" anchor="ctr"/>
-          <a:lstStyle>
-            <a:lvl1pPr algn="l">
-              <a:defRPr sz="1200">
-                <a:solidFill>
-                  <a:schemeClr val="tx1">
-                    <a:tint val="75000"/>
-                  </a:schemeClr>
-                </a:solidFill>
-              </a:defRPr>
-            </a:lvl1pPr>
-          </a:lstStyle>
-          <a:p>
+          <a:lstStyle/>
+          <a:p>
+            <a:pPr>
+              <a:defRPr/>
+            </a:pPr>
             <a:fld id="{BCC18F51-09EC-435C-A3BA-64A766E099C0}" type="datetimeFigureOut">
-              <a:rPr lang="zh-CN" smtClean="0"/>
-              <a:t>30.10.2013</a:t>
+              <a:rPr lang="en-US" altLang="zh-CN"/>
+              <a:t>2026/4/10</a:t>
             </a:fld>
             <a:endParaRPr lang="zh-CN"/>
           </a:p>
@@ -3024,7 +3251,7 @@
       </p:sp>
       <p:sp>
         <p:nvSpPr>
-          <p:cNvPr id="5" name="Footer Placeholder 4"/>
+          <p:cNvPr id="278204060" name="页脚占位符 4"/>
           <p:cNvSpPr>
             <a:spLocks noGrp="1"/>
           </p:cNvSpPr>
@@ -3032,7 +3259,7 @@
             <p:ph type="ftr" sz="quarter" idx="3"/>
           </p:nvPr>
         </p:nvSpPr>
-        <p:spPr>
+        <p:spPr bwMode="auto">
           <a:xfrm>
             <a:off x="4038600" y="6356350"/>
             <a:ext cx="4114800" cy="365125"/>
@@ -3043,25 +3270,18 @@
         </p:spPr>
         <p:txBody>
           <a:bodyPr vert="horz" lIns="91440" tIns="45720" rIns="91440" bIns="45720" rtlCol="0" anchor="ctr"/>
-          <a:lstStyle>
-            <a:lvl1pPr algn="ctr">
-              <a:defRPr sz="1200">
-                <a:solidFill>
-                  <a:schemeClr val="tx1">
-                    <a:tint val="75000"/>
-                  </a:schemeClr>
-                </a:solidFill>
-              </a:defRPr>
-            </a:lvl1pPr>
-          </a:lstStyle>
-          <a:p>
+          <a:lstStyle/>
+          <a:p>
+            <a:pPr>
+              <a:defRPr/>
+            </a:pPr>
             <a:endParaRPr lang="zh-CN"/>
           </a:p>
         </p:txBody>
       </p:sp>
       <p:sp>
         <p:nvSpPr>
-          <p:cNvPr id="6" name="Slide Number Placeholder 5"/>
+          <p:cNvPr id="349809884" name="灯片编号占位符 5"/>
           <p:cNvSpPr>
             <a:spLocks noGrp="1"/>
           </p:cNvSpPr>
@@ -3069,7 +3289,7 @@
             <p:ph type="sldNum" sz="quarter" idx="4"/>
           </p:nvPr>
         </p:nvSpPr>
-        <p:spPr>
+        <p:spPr bwMode="auto">
           <a:xfrm>
             <a:off x="8610600" y="6356350"/>
             <a:ext cx="2743200" cy="365125"/>
@@ -3080,20 +3300,13 @@
         </p:spPr>
         <p:txBody>
           <a:bodyPr vert="horz" lIns="91440" tIns="45720" rIns="91440" bIns="45720" rtlCol="0" anchor="ctr"/>
-          <a:lstStyle>
-            <a:lvl1pPr algn="r">
-              <a:defRPr sz="1200">
-                <a:solidFill>
-                  <a:schemeClr val="tx1">
-                    <a:tint val="75000"/>
-                  </a:schemeClr>
-                </a:solidFill>
-              </a:defRPr>
-            </a:lvl1pPr>
-          </a:lstStyle>
-          <a:p>
+          <a:lstStyle/>
+          <a:p>
+            <a:pPr>
+              <a:defRPr/>
+            </a:pPr>
             <a:fld id="{08395586-F03A-48D1-94DF-16B239DF4FB5}" type="slidenum">
-              <a:rPr lang="zh-CN" smtClean="0"/>
+              <a:rPr lang="zh-CN"/>
               <a:t>‹#›</a:t>
             </a:fld>
             <a:endParaRPr lang="zh-CN"/>
@@ -3101,37 +3314,32 @@
         </p:txBody>
       </p:sp>
     </p:spTree>
-    <p:extLst>
-      <p:ext uri="{BB962C8B-B14F-4D97-AF65-F5344CB8AC3E}">
-        <p14:creationId xmlns:p14="http://schemas.microsoft.com/office/powerpoint/2010/main" val="4124136512"/>
-      </p:ext>
-    </p:extLst>
   </p:cSld>
   <p:clrMap bg1="lt1" tx1="dk1" bg2="lt2" tx2="dk2" accent1="accent1" accent2="accent2" accent3="accent3" accent4="accent4" accent5="accent5" accent6="accent6" hlink="hlink" folHlink="folHlink"/>
   <p:sldLayoutIdLst>
-    <p:sldLayoutId id="2147483673" r:id="rId1"/>
-    <p:sldLayoutId id="2147483674" r:id="rId2"/>
-    <p:sldLayoutId id="2147483675" r:id="rId3"/>
-    <p:sldLayoutId id="2147483676" r:id="rId4"/>
-    <p:sldLayoutId id="2147483677" r:id="rId5"/>
-    <p:sldLayoutId id="2147483678" r:id="rId6"/>
-    <p:sldLayoutId id="2147483679" r:id="rId7"/>
-    <p:sldLayoutId id="2147483680" r:id="rId8"/>
-    <p:sldLayoutId id="2147483681" r:id="rId9"/>
-    <p:sldLayoutId id="2147483682" r:id="rId10"/>
-    <p:sldLayoutId id="2147483683" r:id="rId11"/>
+    <p:sldLayoutId id="2147483649" r:id="rId1"/>
+    <p:sldLayoutId id="2147483650" r:id="rId2"/>
+    <p:sldLayoutId id="2147483651" r:id="rId3"/>
+    <p:sldLayoutId id="2147483652" r:id="rId4"/>
+    <p:sldLayoutId id="2147483653" r:id="rId5"/>
+    <p:sldLayoutId id="2147483654" r:id="rId6"/>
+    <p:sldLayoutId id="2147483655" r:id="rId7"/>
+    <p:sldLayoutId id="2147483656" r:id="rId8"/>
+    <p:sldLayoutId id="2147483657" r:id="rId9"/>
+    <p:sldLayoutId id="2147483658" r:id="rId10"/>
+    <p:sldLayoutId id="2147483659" r:id="rId11"/>
   </p:sldLayoutIdLst>
   <p:txStyles>
     <p:titleStyle>
-      <a:lvl1pPr algn="l" defTabSz="914400" rtl="0" eaLnBrk="1" latinLnBrk="0" hangingPunct="1">
+      <a:lvl1pPr algn="l" defTabSz="914400" rtl="0">
         <a:lnSpc>
           <a:spcPct val="90000"/>
         </a:lnSpc>
         <a:spcBef>
-          <a:spcPct val="0"/>
+          <a:spcPts val="0"/>
         </a:spcBef>
         <a:buNone/>
-        <a:defRPr sz="4400" kern="1200">
+        <a:defRPr sz="4400">
           <a:solidFill>
             <a:schemeClr val="tx1"/>
           </a:solidFill>
@@ -3142,16 +3350,16 @@
       </a:lvl1pPr>
     </p:titleStyle>
     <p:bodyStyle>
-      <a:lvl1pPr marL="228600" indent="-228600" algn="l" defTabSz="914400" rtl="0" eaLnBrk="1" latinLnBrk="0" hangingPunct="1">
+      <a:lvl1pPr marL="228600" indent="-228600" algn="l" defTabSz="914400" rtl="0">
         <a:lnSpc>
           <a:spcPct val="90000"/>
         </a:lnSpc>
         <a:spcBef>
           <a:spcPts val="1000"/>
         </a:spcBef>
-        <a:buFont typeface="Arial" panose="020B0604020202020204" pitchFamily="34" charset="0"/>
+        <a:buFont typeface="Arial"/>
         <a:buChar char="•"/>
-        <a:defRPr sz="2800" kern="1200">
+        <a:defRPr sz="2800">
           <a:solidFill>
             <a:schemeClr val="tx1"/>
           </a:solidFill>
@@ -3160,16 +3368,16 @@
           <a:cs typeface="+mn-cs"/>
         </a:defRPr>
       </a:lvl1pPr>
-      <a:lvl2pPr marL="685800" indent="-228600" algn="l" defTabSz="914400" rtl="0" eaLnBrk="1" latinLnBrk="0" hangingPunct="1">
+      <a:lvl2pPr marL="685800" indent="-228600" algn="l" defTabSz="914400" rtl="0">
         <a:lnSpc>
           <a:spcPct val="90000"/>
         </a:lnSpc>
         <a:spcBef>
           <a:spcPts val="500"/>
         </a:spcBef>
-        <a:buFont typeface="Arial" panose="020B0604020202020204" pitchFamily="34" charset="0"/>
+        <a:buFont typeface="Arial"/>
         <a:buChar char="•"/>
-        <a:defRPr sz="2400" kern="1200">
+        <a:defRPr sz="2400">
           <a:solidFill>
             <a:schemeClr val="tx1"/>
           </a:solidFill>
@@ -3178,16 +3386,16 @@
           <a:cs typeface="+mn-cs"/>
         </a:defRPr>
       </a:lvl2pPr>
-      <a:lvl3pPr marL="1143000" indent="-228600" algn="l" defTabSz="914400" rtl="0" eaLnBrk="1" latinLnBrk="0" hangingPunct="1">
+      <a:lvl3pPr marL="1143000" indent="-228600" algn="l" defTabSz="914400" rtl="0">
         <a:lnSpc>
           <a:spcPct val="90000"/>
         </a:lnSpc>
         <a:spcBef>
           <a:spcPts val="500"/>
         </a:spcBef>
-        <a:buFont typeface="Arial" panose="020B0604020202020204" pitchFamily="34" charset="0"/>
+        <a:buFont typeface="Arial"/>
         <a:buChar char="•"/>
-        <a:defRPr sz="2000" kern="1200">
+        <a:defRPr sz="2000">
           <a:solidFill>
             <a:schemeClr val="tx1"/>
           </a:solidFill>
@@ -3196,16 +3404,16 @@
           <a:cs typeface="+mn-cs"/>
         </a:defRPr>
       </a:lvl3pPr>
-      <a:lvl4pPr marL="1600200" indent="-228600" algn="l" defTabSz="914400" rtl="0" eaLnBrk="1" latinLnBrk="0" hangingPunct="1">
+      <a:lvl4pPr marL="1600200" indent="-228600" algn="l" defTabSz="914400" rtl="0">
         <a:lnSpc>
           <a:spcPct val="90000"/>
         </a:lnSpc>
         <a:spcBef>
           <a:spcPts val="500"/>
         </a:spcBef>
-        <a:buFont typeface="Arial" panose="020B0604020202020204" pitchFamily="34" charset="0"/>
+        <a:buFont typeface="Arial"/>
         <a:buChar char="•"/>
-        <a:defRPr sz="1800" kern="1200">
+        <a:defRPr sz="1800">
           <a:solidFill>
             <a:schemeClr val="tx1"/>
           </a:solidFill>
@@ -3214,16 +3422,16 @@
           <a:cs typeface="+mn-cs"/>
         </a:defRPr>
       </a:lvl4pPr>
-      <a:lvl5pPr marL="2057400" indent="-228600" algn="l" defTabSz="914400" rtl="0" eaLnBrk="1" latinLnBrk="0" hangingPunct="1">
+      <a:lvl5pPr marL="2057400" indent="-228600" algn="l" defTabSz="914400" rtl="0">
         <a:lnSpc>
           <a:spcPct val="90000"/>
         </a:lnSpc>
         <a:spcBef>
           <a:spcPts val="500"/>
         </a:spcBef>
-        <a:buFont typeface="Arial" panose="020B0604020202020204" pitchFamily="34" charset="0"/>
+        <a:buFont typeface="Arial"/>
         <a:buChar char="•"/>
-        <a:defRPr sz="1800" kern="1200">
+        <a:defRPr sz="1800">
           <a:solidFill>
             <a:schemeClr val="tx1"/>
           </a:solidFill>
@@ -3232,16 +3440,16 @@
           <a:cs typeface="+mn-cs"/>
         </a:defRPr>
       </a:lvl5pPr>
-      <a:lvl6pPr marL="2514600" indent="-228600" algn="l" defTabSz="914400" rtl="0" eaLnBrk="1" latinLnBrk="0" hangingPunct="1">
+      <a:lvl6pPr marL="2514600" indent="-228600" algn="l" defTabSz="914400" rtl="0">
         <a:lnSpc>
           <a:spcPct val="90000"/>
         </a:lnSpc>
         <a:spcBef>
           <a:spcPts val="500"/>
         </a:spcBef>
-        <a:buFont typeface="Arial" panose="020B0604020202020204" pitchFamily="34" charset="0"/>
+        <a:buFont typeface="Arial"/>
         <a:buChar char="•"/>
-        <a:defRPr sz="1800" kern="1200">
+        <a:defRPr sz="1800">
           <a:solidFill>
             <a:schemeClr val="tx1"/>
           </a:solidFill>
@@ -3250,16 +3458,16 @@
           <a:cs typeface="+mn-cs"/>
         </a:defRPr>
       </a:lvl6pPr>
-      <a:lvl7pPr marL="2971800" indent="-228600" algn="l" defTabSz="914400" rtl="0" eaLnBrk="1" latinLnBrk="0" hangingPunct="1">
+      <a:lvl7pPr marL="2971800" indent="-228600" algn="l" defTabSz="914400" rtl="0">
         <a:lnSpc>
           <a:spcPct val="90000"/>
         </a:lnSpc>
         <a:spcBef>
           <a:spcPts val="500"/>
         </a:spcBef>
-        <a:buFont typeface="Arial" panose="020B0604020202020204" pitchFamily="34" charset="0"/>
+        <a:buFont typeface="Arial"/>
         <a:buChar char="•"/>
-        <a:defRPr sz="1800" kern="1200">
+        <a:defRPr sz="1800">
           <a:solidFill>
             <a:schemeClr val="tx1"/>
           </a:solidFill>
@@ -3268,16 +3476,16 @@
           <a:cs typeface="+mn-cs"/>
         </a:defRPr>
       </a:lvl7pPr>
-      <a:lvl8pPr marL="3429000" indent="-228600" algn="l" defTabSz="914400" rtl="0" eaLnBrk="1" latinLnBrk="0" hangingPunct="1">
+      <a:lvl8pPr marL="3429000" indent="-228600" algn="l" defTabSz="914400" rtl="0">
         <a:lnSpc>
           <a:spcPct val="90000"/>
         </a:lnSpc>
         <a:spcBef>
           <a:spcPts val="500"/>
         </a:spcBef>
-        <a:buFont typeface="Arial" panose="020B0604020202020204" pitchFamily="34" charset="0"/>
+        <a:buFont typeface="Arial"/>
         <a:buChar char="•"/>
-        <a:defRPr sz="1800" kern="1200">
+        <a:defRPr sz="1800">
           <a:solidFill>
             <a:schemeClr val="tx1"/>
           </a:solidFill>
@@ -3286,16 +3494,16 @@
           <a:cs typeface="+mn-cs"/>
         </a:defRPr>
       </a:lvl8pPr>
-      <a:lvl9pPr marL="3886200" indent="-228600" algn="l" defTabSz="914400" rtl="0" eaLnBrk="1" latinLnBrk="0" hangingPunct="1">
+      <a:lvl9pPr marL="3886200" indent="-228600" algn="l" defTabSz="914400" rtl="0">
         <a:lnSpc>
           <a:spcPct val="90000"/>
         </a:lnSpc>
         <a:spcBef>
           <a:spcPts val="500"/>
         </a:spcBef>
-        <a:buFont typeface="Arial" panose="020B0604020202020204" pitchFamily="34" charset="0"/>
+        <a:buFont typeface="Arial"/>
         <a:buChar char="•"/>
-        <a:defRPr sz="1800" kern="1200">
+        <a:defRPr sz="1800">
           <a:solidFill>
             <a:schemeClr val="tx1"/>
           </a:solidFill>
@@ -3309,8 +3517,8 @@
       <a:defPPr>
         <a:defRPr lang="zh-CN"/>
       </a:defPPr>
-      <a:lvl1pPr marL="0" algn="l" defTabSz="914400" rtl="0" eaLnBrk="1" latinLnBrk="0" hangingPunct="1">
-        <a:defRPr sz="1800" kern="1200">
+      <a:lvl1pPr marL="0" algn="l" defTabSz="914400" rtl="0">
+        <a:defRPr sz="1800">
           <a:solidFill>
             <a:schemeClr val="tx1"/>
           </a:solidFill>
@@ -3319,8 +3527,8 @@
           <a:cs typeface="+mn-cs"/>
         </a:defRPr>
       </a:lvl1pPr>
-      <a:lvl2pPr marL="457200" algn="l" defTabSz="914400" rtl="0" eaLnBrk="1" latinLnBrk="0" hangingPunct="1">
-        <a:defRPr sz="1800" kern="1200">
+      <a:lvl2pPr marL="457200" algn="l" defTabSz="914400" rtl="0">
+        <a:defRPr sz="1800">
           <a:solidFill>
             <a:schemeClr val="tx1"/>
           </a:solidFill>
@@ -3329,8 +3537,8 @@
           <a:cs typeface="+mn-cs"/>
         </a:defRPr>
       </a:lvl2pPr>
-      <a:lvl3pPr marL="914400" algn="l" defTabSz="914400" rtl="0" eaLnBrk="1" latinLnBrk="0" hangingPunct="1">
-        <a:defRPr sz="1800" kern="1200">
+      <a:lvl3pPr marL="914400" algn="l" defTabSz="914400" rtl="0">
+        <a:defRPr sz="1800">
           <a:solidFill>
             <a:schemeClr val="tx1"/>
           </a:solidFill>
@@ -3339,8 +3547,8 @@
           <a:cs typeface="+mn-cs"/>
         </a:defRPr>
       </a:lvl3pPr>
-      <a:lvl4pPr marL="1371600" algn="l" defTabSz="914400" rtl="0" eaLnBrk="1" latinLnBrk="0" hangingPunct="1">
-        <a:defRPr sz="1800" kern="1200">
+      <a:lvl4pPr marL="1371600" algn="l" defTabSz="914400" rtl="0">
+        <a:defRPr sz="1800">
           <a:solidFill>
             <a:schemeClr val="tx1"/>
           </a:solidFill>
@@ -3349,8 +3557,8 @@
           <a:cs typeface="+mn-cs"/>
         </a:defRPr>
       </a:lvl4pPr>
-      <a:lvl5pPr marL="1828800" algn="l" defTabSz="914400" rtl="0" eaLnBrk="1" latinLnBrk="0" hangingPunct="1">
-        <a:defRPr sz="1800" kern="1200">
+      <a:lvl5pPr marL="1828800" algn="l" defTabSz="914400" rtl="0">
+        <a:defRPr sz="1800">
           <a:solidFill>
             <a:schemeClr val="tx1"/>
           </a:solidFill>
@@ -3359,8 +3567,8 @@
           <a:cs typeface="+mn-cs"/>
         </a:defRPr>
       </a:lvl5pPr>
-      <a:lvl6pPr marL="2286000" algn="l" defTabSz="914400" rtl="0" eaLnBrk="1" latinLnBrk="0" hangingPunct="1">
-        <a:defRPr sz="1800" kern="1200">
+      <a:lvl6pPr marL="2286000" algn="l" defTabSz="914400" rtl="0">
+        <a:defRPr sz="1800">
           <a:solidFill>
             <a:schemeClr val="tx1"/>
           </a:solidFill>
@@ -3369,8 +3577,8 @@
           <a:cs typeface="+mn-cs"/>
         </a:defRPr>
       </a:lvl6pPr>
-      <a:lvl7pPr marL="2743200" algn="l" defTabSz="914400" rtl="0" eaLnBrk="1" latinLnBrk="0" hangingPunct="1">
-        <a:defRPr sz="1800" kern="1200">
+      <a:lvl7pPr marL="2743200" algn="l" defTabSz="914400" rtl="0">
+        <a:defRPr sz="1800">
           <a:solidFill>
             <a:schemeClr val="tx1"/>
           </a:solidFill>
@@ -3379,8 +3587,8 @@
           <a:cs typeface="+mn-cs"/>
         </a:defRPr>
       </a:lvl7pPr>
-      <a:lvl8pPr marL="3200400" algn="l" defTabSz="914400" rtl="0" eaLnBrk="1" latinLnBrk="0" hangingPunct="1">
-        <a:defRPr sz="1800" kern="1200">
+      <a:lvl8pPr marL="3200400" algn="l" defTabSz="914400" rtl="0">
+        <a:defRPr sz="1800">
           <a:solidFill>
             <a:schemeClr val="tx1"/>
           </a:solidFill>
@@ -3389,8 +3597,8 @@
           <a:cs typeface="+mn-cs"/>
         </a:defRPr>
       </a:lvl8pPr>
-      <a:lvl9pPr marL="3657600" algn="l" defTabSz="914400" rtl="0" eaLnBrk="1" latinLnBrk="0" hangingPunct="1">
-        <a:defRPr sz="1800" kern="1200">
+      <a:lvl9pPr marL="3657600" algn="l" defTabSz="914400" rtl="0">
+        <a:defRPr sz="1800">
           <a:solidFill>
             <a:schemeClr val="tx1"/>
           </a:solidFill>
@@ -3405,7 +3613,7 @@
 </file>
 
 <file path=ppt/slides/slide1.xml><?xml version="1.0" encoding="utf-8"?>
-<p:sld xmlns:a="http://schemas.openxmlformats.org/drawingml/2006/main" xmlns:r="http://schemas.openxmlformats.org/officeDocument/2006/relationships" xmlns:p="http://schemas.openxmlformats.org/presentationml/2006/main">
+<p:sld xmlns:a="http://schemas.openxmlformats.org/drawingml/2006/main" xmlns:r="http://schemas.openxmlformats.org/officeDocument/2006/relationships" xmlns:p="http://schemas.openxmlformats.org/presentationml/2006/main" showMasterPhAnim="0">
   <p:cSld>
     <p:spTree>
       <p:nvGrpSpPr>
@@ -3413,7 +3621,7 @@
         <p:cNvGrpSpPr/>
         <p:nvPr/>
       </p:nvGrpSpPr>
-      <p:grpSpPr>
+      <p:grpSpPr bwMode="auto">
         <a:xfrm>
           <a:off x="0" y="0"/>
           <a:ext cx="0" cy="0"/>
@@ -3423,7 +3631,7 @@
       </p:grpSpPr>
       <p:sp>
         <p:nvSpPr>
-          <p:cNvPr id="2" name="Title 1"/>
+          <p:cNvPr id="1206612760" name="标题 1"/>
           <p:cNvSpPr>
             <a:spLocks noGrp="1"/>
           </p:cNvSpPr>
@@ -3431,7 +3639,7 @@
             <p:ph type="ctrTitle"/>
           </p:nvPr>
         </p:nvSpPr>
-        <p:spPr/>
+        <p:spPr bwMode="auto"/>
         <p:txBody>
           <a:bodyPr/>
           <a:lstStyle/>
@@ -3442,7 +3650,7 @@
       </p:sp>
       <p:sp>
         <p:nvSpPr>
-          <p:cNvPr id="3" name="Subtitle 2"/>
+          <p:cNvPr id="37649361" name="副标题 2"/>
           <p:cNvSpPr>
             <a:spLocks noGrp="1"/>
           </p:cNvSpPr>
@@ -3450,7 +3658,7 @@
             <p:ph type="subTitle" idx="1"/>
           </p:nvPr>
         </p:nvSpPr>
-        <p:spPr/>
+        <p:spPr bwMode="auto"/>
         <p:txBody>
           <a:bodyPr/>
           <a:lstStyle/>
@@ -3460,11 +3668,6 @@
         </p:txBody>
       </p:sp>
     </p:spTree>
-    <p:extLst>
-      <p:ext uri="{BB962C8B-B14F-4D97-AF65-F5344CB8AC3E}">
-        <p14:creationId xmlns:p14="http://schemas.microsoft.com/office/powerpoint/2010/main" val="2426011969"/>
-      </p:ext>
-    </p:extLst>
   </p:cSld>
   <p:clrMapOvr>
     <a:masterClrMapping/>
@@ -3515,12 +3718,12 @@
     </a:clrScheme>
     <a:fontScheme name="Office Theme">
       <a:majorFont>
-        <a:latin typeface="Arial" panose="020F0302020204030204"/>
+        <a:latin typeface="等线 Light" panose="020F0302020204030204"/>
         <a:ea typeface=""/>
         <a:cs typeface=""/>
-        <a:font script="Jpan" typeface="ＭＳ Ｐゴシック"/>
+        <a:font script="Jpan" typeface="游ゴシック Light"/>
         <a:font script="Hang" typeface="맑은 고딕"/>
-        <a:font script="Hans" typeface="宋体"/>
+        <a:font script="Hans" typeface="等线 Light"/>
         <a:font script="Hant" typeface="新細明體"/>
         <a:font script="Arab" typeface="Times New Roman"/>
         <a:font script="Hebr" typeface="Times New Roman"/>
@@ -3548,14 +3751,31 @@
         <a:font script="Viet" typeface="Times New Roman"/>
         <a:font script="Uigh" typeface="Microsoft Uighur"/>
         <a:font script="Geor" typeface="Sylfaen"/>
+        <a:font script="Armn" typeface="Arial"/>
+        <a:font script="Bugi" typeface="Leelawadee UI"/>
+        <a:font script="Bopo" typeface="Microsoft JhengHei"/>
+        <a:font script="Java" typeface="Javanese Text"/>
+        <a:font script="Lisu" typeface="Segoe UI"/>
+        <a:font script="Mymr" typeface="Myanmar Text"/>
+        <a:font script="Nkoo" typeface="Ebrima"/>
+        <a:font script="Olck" typeface="Nirmala UI"/>
+        <a:font script="Osma" typeface="Ebrima"/>
+        <a:font script="Phag" typeface="Phagspa"/>
+        <a:font script="Syrn" typeface="Estrangelo Edessa"/>
+        <a:font script="Syrj" typeface="Estrangelo Edessa"/>
+        <a:font script="Syre" typeface="Estrangelo Edessa"/>
+        <a:font script="Sora" typeface="Nirmala UI"/>
+        <a:font script="Tale" typeface="Microsoft Tai Le"/>
+        <a:font script="Talu" typeface="Microsoft New Tai Lue"/>
+        <a:font script="Tfng" typeface="Ebrima"/>
       </a:majorFont>
       <a:minorFont>
-        <a:latin typeface="Arial" panose="020F0502020204030204"/>
+        <a:latin typeface="等线" panose="020F0502020204030204"/>
         <a:ea typeface=""/>
         <a:cs typeface=""/>
-        <a:font script="Jpan" typeface="ＭＳ Ｐゴシック"/>
+        <a:font script="Jpan" typeface="游ゴシック"/>
         <a:font script="Hang" typeface="맑은 고딕"/>
-        <a:font script="Hans" typeface="宋体"/>
+        <a:font script="Hans" typeface="等线"/>
         <a:font script="Hant" typeface="新細明體"/>
         <a:font script="Arab" typeface="Arial"/>
         <a:font script="Hebr" typeface="Arial"/>
@@ -3583,6 +3803,23 @@
         <a:font script="Viet" typeface="Arial"/>
         <a:font script="Uigh" typeface="Microsoft Uighur"/>
         <a:font script="Geor" typeface="Sylfaen"/>
+        <a:font script="Armn" typeface="Arial"/>
+        <a:font script="Bugi" typeface="Leelawadee UI"/>
+        <a:font script="Bopo" typeface="Microsoft JhengHei"/>
+        <a:font script="Java" typeface="Javanese Text"/>
+        <a:font script="Lisu" typeface="Segoe UI"/>
+        <a:font script="Mymr" typeface="Myanmar Text"/>
+        <a:font script="Nkoo" typeface="Ebrima"/>
+        <a:font script="Olck" typeface="Nirmala UI"/>
+        <a:font script="Osma" typeface="Ebrima"/>
+        <a:font script="Phag" typeface="Phagspa"/>
+        <a:font script="Syrn" typeface="Estrangelo Edessa"/>
+        <a:font script="Syrj" typeface="Estrangelo Edessa"/>
+        <a:font script="Syre" typeface="Estrangelo Edessa"/>
+        <a:font script="Sora" typeface="Nirmala UI"/>
+        <a:font script="Tale" typeface="Microsoft Tai Le"/>
+        <a:font script="Talu" typeface="Microsoft New Tai Lue"/>
+        <a:font script="Tfng" typeface="Ebrima"/>
       </a:minorFont>
     </a:fontScheme>
     <a:fmtScheme name="Office Theme">
@@ -3750,7 +3987,7 @@
         <a:srgbClr val="E7E6E6"/>
       </a:lt2>
       <a:accent1>
-        <a:srgbClr val="5B9BD5"/>
+        <a:srgbClr val="4472C4"/>
       </a:accent1>
       <a:accent2>
         <a:srgbClr val="ED7D31"/>
@@ -3762,7 +3999,7 @@
         <a:srgbClr val="FFC000"/>
       </a:accent4>
       <a:accent5>
-        <a:srgbClr val="4472C4"/>
+        <a:srgbClr val="5B9BD5"/>
       </a:accent5>
       <a:accent6>
         <a:srgbClr val="70AD47"/>
@@ -3774,18 +4011,70 @@
         <a:srgbClr val="954F72"/>
       </a:folHlink>
     </a:clrScheme>
-    <a:fontScheme name="Arial">
+    <a:fontScheme name="Office">
       <a:majorFont>
-        <a:latin typeface="Arial" panose="020B0604020202020204"/>
+        <a:latin typeface="Calibri Light" panose="020F0302020204030204"/>
         <a:ea typeface=""/>
         <a:cs typeface=""/>
-        <a:font script="Jpan" typeface="ＭＳ ゴシック"/>
+        <a:font script="Jpan" typeface="游ゴシック Light"/>
         <a:font script="Hang" typeface="맑은 고딕"/>
-        <a:font script="Hans" typeface="宋体"/>
+        <a:font script="Hans" typeface="等线 Light"/>
         <a:font script="Hant" typeface="新細明體"/>
-        <a:font script="Arab" typeface="Tahoma"/>
-        <a:font script="Hebr" typeface="Gisha"/>
-        <a:font script="Thai" typeface="DilleniaUPC"/>
+        <a:font script="Arab" typeface="Times New Roman"/>
+        <a:font script="Hebr" typeface="Times New Roman"/>
+        <a:font script="Thai" typeface="Angsana New"/>
+        <a:font script="Ethi" typeface="Nyala"/>
+        <a:font script="Beng" typeface="Vrinda"/>
+        <a:font script="Gujr" typeface="Shruti"/>
+        <a:font script="Khmr" typeface="MoolBoran"/>
+        <a:font script="Knda" typeface="Tunga"/>
+        <a:font script="Guru" typeface="Raavi"/>
+        <a:font script="Cans" typeface="Euphemia"/>
+        <a:font script="Cher" typeface="Plantagenet Cherokee"/>
+        <a:font script="Yiii" typeface="Microsoft Yi Baiti"/>
+        <a:font script="Tibt" typeface="Microsoft Himalaya"/>
+        <a:font script="Thaa" typeface="MV Boli"/>
+        <a:font script="Deva" typeface="Mangal"/>
+        <a:font script="Telu" typeface="Gautami"/>
+        <a:font script="Taml" typeface="Latha"/>
+        <a:font script="Syrc" typeface="Estrangelo Edessa"/>
+        <a:font script="Orya" typeface="Kalinga"/>
+        <a:font script="Mlym" typeface="Kartika"/>
+        <a:font script="Laoo" typeface="DokChampa"/>
+        <a:font script="Sinh" typeface="Iskoola Pota"/>
+        <a:font script="Mong" typeface="Mongolian Baiti"/>
+        <a:font script="Viet" typeface="Times New Roman"/>
+        <a:font script="Uigh" typeface="Microsoft Uighur"/>
+        <a:font script="Geor" typeface="Sylfaen"/>
+        <a:font script="Armn" typeface="Arial"/>
+        <a:font script="Bugi" typeface="Leelawadee UI"/>
+        <a:font script="Bopo" typeface="Microsoft JhengHei"/>
+        <a:font script="Java" typeface="Javanese Text"/>
+        <a:font script="Lisu" typeface="Segoe UI"/>
+        <a:font script="Mymr" typeface="Myanmar Text"/>
+        <a:font script="Nkoo" typeface="Ebrima"/>
+        <a:font script="Olck" typeface="Nirmala UI"/>
+        <a:font script="Osma" typeface="Ebrima"/>
+        <a:font script="Phag" typeface="Phagspa"/>
+        <a:font script="Syrn" typeface="Estrangelo Edessa"/>
+        <a:font script="Syrj" typeface="Estrangelo Edessa"/>
+        <a:font script="Syre" typeface="Estrangelo Edessa"/>
+        <a:font script="Sora" typeface="Nirmala UI"/>
+        <a:font script="Tale" typeface="Microsoft Tai Le"/>
+        <a:font script="Talu" typeface="Microsoft New Tai Lue"/>
+        <a:font script="Tfng" typeface="Ebrima"/>
+      </a:majorFont>
+      <a:minorFont>
+        <a:latin typeface="Calibri" panose="020F0502020204030204"/>
+        <a:ea typeface=""/>
+        <a:cs typeface=""/>
+        <a:font script="Jpan" typeface="游ゴシック"/>
+        <a:font script="Hang" typeface="맑은 고딕"/>
+        <a:font script="Hans" typeface="等线"/>
+        <a:font script="Hant" typeface="新細明體"/>
+        <a:font script="Arab" typeface="Arial"/>
+        <a:font script="Hebr" typeface="Arial"/>
+        <a:font script="Thai" typeface="Cordia New"/>
         <a:font script="Ethi" typeface="Nyala"/>
         <a:font script="Beng" typeface="Vrinda"/>
         <a:font script="Gujr" typeface="Shruti"/>
@@ -3806,44 +4095,26 @@
         <a:font script="Laoo" typeface="DokChampa"/>
         <a:font script="Sinh" typeface="Iskoola Pota"/>
         <a:font script="Mong" typeface="Mongolian Baiti"/>
-        <a:font script="Viet" typeface="Tahoma"/>
+        <a:font script="Viet" typeface="Arial"/>
         <a:font script="Uigh" typeface="Microsoft Uighur"/>
         <a:font script="Geor" typeface="Sylfaen"/>
-      </a:majorFont>
-      <a:minorFont>
-        <a:latin typeface="Arial" panose="020B0604020202020204"/>
-        <a:ea typeface=""/>
-        <a:cs typeface=""/>
-        <a:font script="Jpan" typeface="ＭＳ ゴシック"/>
-        <a:font script="Hang" typeface="맑은 고딕"/>
-        <a:font script="Hans" typeface="宋体"/>
-        <a:font script="Hant" typeface="新細明體"/>
-        <a:font script="Arab" typeface="Tahoma"/>
-        <a:font script="Hebr" typeface="Gisha"/>
-        <a:font script="Thai" typeface="DilleniaUPC"/>
-        <a:font script="Ethi" typeface="Nyala"/>
-        <a:font script="Beng" typeface="Vrinda"/>
-        <a:font script="Gujr" typeface="Shruti"/>
-        <a:font script="Khmr" typeface="DaunPenh"/>
-        <a:font script="Knda" typeface="Tunga"/>
-        <a:font script="Guru" typeface="Raavi"/>
-        <a:font script="Cans" typeface="Euphemia"/>
-        <a:font script="Cher" typeface="Plantagenet Cherokee"/>
-        <a:font script="Yiii" typeface="Microsoft Yi Baiti"/>
-        <a:font script="Tibt" typeface="Microsoft Himalaya"/>
-        <a:font script="Thaa" typeface="MV Boli"/>
-        <a:font script="Deva" typeface="Mangal"/>
-        <a:font script="Telu" typeface="Gautami"/>
-        <a:font script="Taml" typeface="Latha"/>
-        <a:font script="Syrc" typeface="Estrangelo Edessa"/>
-        <a:font script="Orya" typeface="Kalinga"/>
-        <a:font script="Mlym" typeface="Kartika"/>
-        <a:font script="Laoo" typeface="DokChampa"/>
-        <a:font script="Sinh" typeface="Iskoola Pota"/>
-        <a:font script="Mong" typeface="Mongolian Baiti"/>
-        <a:font script="Viet" typeface="Verdana"/>
-        <a:font script="Uigh" typeface="Microsoft Uighur"/>
-        <a:font script="Geor" typeface="Sylfaen"/>
+        <a:font script="Armn" typeface="Arial"/>
+        <a:font script="Bugi" typeface="Leelawadee UI"/>
+        <a:font script="Bopo" typeface="Microsoft JhengHei"/>
+        <a:font script="Java" typeface="Javanese Text"/>
+        <a:font script="Lisu" typeface="Segoe UI"/>
+        <a:font script="Mymr" typeface="Myanmar Text"/>
+        <a:font script="Nkoo" typeface="Ebrima"/>
+        <a:font script="Olck" typeface="Nirmala UI"/>
+        <a:font script="Osma" typeface="Ebrima"/>
+        <a:font script="Phag" typeface="Phagspa"/>
+        <a:font script="Syrn" typeface="Estrangelo Edessa"/>
+        <a:font script="Syrj" typeface="Estrangelo Edessa"/>
+        <a:font script="Syre" typeface="Estrangelo Edessa"/>
+        <a:font script="Sora" typeface="Nirmala UI"/>
+        <a:font script="Tale" typeface="Microsoft Tai Le"/>
+        <a:font script="Talu" typeface="Microsoft New Tai Lue"/>
+        <a:font script="Tfng" typeface="Ebrima"/>
       </a:minorFont>
     </a:fontScheme>
     <a:fmtScheme name="Office">

</xml_diff>